<commit_message>
Intro slides and Data Structures Complete
</commit_message>
<xml_diff>
--- a/Intro Slides/Course Intro.pptx
+++ b/Intro Slides/Course Intro.pptx
@@ -5,23 +5,22 @@
     <p:sldMasterId id="2147483680" r:id="rId5"/>
   </p:sldMasterIdLst>
   <p:notesMasterIdLst>
-    <p:notesMasterId r:id="rId20"/>
+    <p:notesMasterId r:id="rId19"/>
   </p:notesMasterIdLst>
   <p:sldIdLst>
     <p:sldId id="256" r:id="rId6"/>
-    <p:sldId id="266" r:id="rId7"/>
-    <p:sldId id="257" r:id="rId8"/>
-    <p:sldId id="259" r:id="rId9"/>
+    <p:sldId id="257" r:id="rId7"/>
+    <p:sldId id="259" r:id="rId8"/>
+    <p:sldId id="258" r:id="rId9"/>
     <p:sldId id="264" r:id="rId10"/>
     <p:sldId id="268" r:id="rId11"/>
-    <p:sldId id="265" r:id="rId12"/>
-    <p:sldId id="258" r:id="rId13"/>
-    <p:sldId id="260" r:id="rId14"/>
-    <p:sldId id="262" r:id="rId15"/>
-    <p:sldId id="263" r:id="rId16"/>
-    <p:sldId id="270" r:id="rId17"/>
-    <p:sldId id="267" r:id="rId18"/>
-    <p:sldId id="269" r:id="rId19"/>
+    <p:sldId id="271" r:id="rId12"/>
+    <p:sldId id="260" r:id="rId13"/>
+    <p:sldId id="262" r:id="rId14"/>
+    <p:sldId id="263" r:id="rId15"/>
+    <p:sldId id="270" r:id="rId16"/>
+    <p:sldId id="267" r:id="rId17"/>
+    <p:sldId id="269" r:id="rId18"/>
   </p:sldIdLst>
   <p:sldSz cx="12192000" cy="6858000"/>
   <p:notesSz cx="6858000" cy="9144000"/>
@@ -210,7 +209,7 @@
           <a:p>
             <a:fld id="{691C588C-9717-44ED-B9A9-CBD9D1909AD4}" type="datetimeFigureOut">
               <a:rPr lang="en-US" smtClean="0"/>
-              <a:t>05-May-26</a:t>
+              <a:t>7/7/2026</a:t>
             </a:fld>
             <a:endParaRPr lang="en-US"/>
           </a:p>
@@ -521,6 +520,90 @@
           <a:bodyPr/>
           <a:lstStyle/>
           <a:p>
+            <a:endParaRPr lang="en-US" dirty="0"/>
+          </a:p>
+        </p:txBody>
+      </p:sp>
+      <p:sp>
+        <p:nvSpPr>
+          <p:cNvPr id="4" name="Slide Number Placeholder 3"/>
+          <p:cNvSpPr>
+            <a:spLocks noGrp="1"/>
+          </p:cNvSpPr>
+          <p:nvPr>
+            <p:ph type="sldNum" sz="quarter" idx="5"/>
+          </p:nvPr>
+        </p:nvSpPr>
+        <p:spPr/>
+        <p:txBody>
+          <a:bodyPr/>
+          <a:lstStyle/>
+          <a:p>
+            <a:fld id="{460BBBCE-FA44-432B-84B0-7537B159768C}" type="slidenum">
+              <a:rPr lang="en-US" smtClean="0"/>
+              <a:t>3</a:t>
+            </a:fld>
+            <a:endParaRPr lang="en-US"/>
+          </a:p>
+        </p:txBody>
+      </p:sp>
+    </p:spTree>
+    <p:extLst>
+      <p:ext uri="{BB962C8B-B14F-4D97-AF65-F5344CB8AC3E}">
+        <p14:creationId xmlns:p14="http://schemas.microsoft.com/office/powerpoint/2010/main" val="4059920935"/>
+      </p:ext>
+    </p:extLst>
+  </p:cSld>
+  <p:clrMapOvr>
+    <a:masterClrMapping/>
+  </p:clrMapOvr>
+</p:notes>
+</file>
+
+<file path=ppt/notesSlides/notesSlide2.xml><?xml version="1.0" encoding="utf-8"?>
+<p:notes xmlns:a="http://schemas.openxmlformats.org/drawingml/2006/main" xmlns:r="http://schemas.openxmlformats.org/officeDocument/2006/relationships" xmlns:p="http://schemas.openxmlformats.org/presentationml/2006/main">
+  <p:cSld>
+    <p:spTree>
+      <p:nvGrpSpPr>
+        <p:cNvPr id="1" name=""/>
+        <p:cNvGrpSpPr/>
+        <p:nvPr/>
+      </p:nvGrpSpPr>
+      <p:grpSpPr>
+        <a:xfrm>
+          <a:off x="0" y="0"/>
+          <a:ext cx="0" cy="0"/>
+          <a:chOff x="0" y="0"/>
+          <a:chExt cx="0" cy="0"/>
+        </a:xfrm>
+      </p:grpSpPr>
+      <p:sp>
+        <p:nvSpPr>
+          <p:cNvPr id="2" name="Slide Image Placeholder 1"/>
+          <p:cNvSpPr>
+            <a:spLocks noGrp="1" noRot="1" noChangeAspect="1"/>
+          </p:cNvSpPr>
+          <p:nvPr>
+            <p:ph type="sldImg"/>
+          </p:nvPr>
+        </p:nvSpPr>
+        <p:spPr/>
+      </p:sp>
+      <p:sp>
+        <p:nvSpPr>
+          <p:cNvPr id="3" name="Notes Placeholder 2"/>
+          <p:cNvSpPr>
+            <a:spLocks noGrp="1"/>
+          </p:cNvSpPr>
+          <p:nvPr>
+            <p:ph type="body" idx="1"/>
+          </p:nvPr>
+        </p:nvSpPr>
+        <p:spPr/>
+        <p:txBody>
+          <a:bodyPr/>
+          <a:lstStyle/>
+          <a:p>
             <a:r>
               <a:rPr lang="en-US" dirty="0"/>
               <a:t>Fraction (math) problems</a:t>
@@ -566,7 +649,7 @@
           <a:p>
             <a:fld id="{460BBBCE-FA44-432B-84B0-7537B159768C}" type="slidenum">
               <a:rPr lang="en-US" smtClean="0"/>
-              <a:t>12</a:t>
+              <a:t>11</a:t>
             </a:fld>
             <a:endParaRPr lang="en-US"/>
           </a:p>
@@ -633,7 +716,7 @@
           <a:p>
             <a:fld id="{7A3E0868-4E26-4CDC-8A56-D70E2D8B12FE}" type="datetime3">
               <a:rPr lang="en-US" smtClean="0"/>
-              <a:t>5 May 2026</a:t>
+              <a:t>7 July 2026</a:t>
             </a:fld>
             <a:endParaRPr lang="en-US"/>
           </a:p>
@@ -3194,7 +3277,7 @@
           <a:p>
             <a:fld id="{A7B8021B-6105-4216-96FC-94348F216D0E}" type="datetime3">
               <a:rPr lang="en-US" smtClean="0"/>
-              <a:t>5 May 2026</a:t>
+              <a:t>7 July 2026</a:t>
             </a:fld>
             <a:endParaRPr lang="en-US"/>
           </a:p>
@@ -4891,7 +4974,7 @@
           <a:p>
             <a:fld id="{5D27CFAB-73E6-44A8-B862-B3306344E3F2}" type="datetime3">
               <a:rPr lang="en-US" smtClean="0"/>
-              <a:t>5 May 2026</a:t>
+              <a:t>7 July 2026</a:t>
             </a:fld>
             <a:endParaRPr lang="en-US"/>
           </a:p>
@@ -6681,7 +6764,7 @@
           <a:p>
             <a:fld id="{A9B2E784-A5F5-4301-881B-94AC8DBF9DED}" type="datetime3">
               <a:rPr lang="en-US" smtClean="0"/>
-              <a:t>5 May 2026</a:t>
+              <a:t>7 July 2026</a:t>
             </a:fld>
             <a:endParaRPr lang="en-US"/>
           </a:p>
@@ -6860,7 +6943,7 @@
           <a:p>
             <a:fld id="{18EAB3A5-9E92-4BB9-8F22-9632B4FBEDBA}" type="datetime3">
               <a:rPr lang="en-US" smtClean="0"/>
-              <a:t>5 May 2026</a:t>
+              <a:t>7 July 2026</a:t>
             </a:fld>
             <a:endParaRPr lang="en-US"/>
           </a:p>
@@ -7087,7 +7170,7 @@
           <a:p>
             <a:fld id="{40923810-5FB2-48C9-96CA-1DE2C4773142}" type="datetime3">
               <a:rPr lang="en-US" smtClean="0"/>
-              <a:t>5 May 2026</a:t>
+              <a:t>7 July 2026</a:t>
             </a:fld>
             <a:endParaRPr lang="en-US"/>
           </a:p>
@@ -7377,7 +7460,7 @@
           <a:p>
             <a:fld id="{E50EFF4B-86EB-42FB-93EA-7D8F9CB2466F}" type="datetime3">
               <a:rPr lang="en-US" smtClean="0"/>
-              <a:t>5 May 2026</a:t>
+              <a:t>7 July 2026</a:t>
             </a:fld>
             <a:endParaRPr lang="en-US"/>
           </a:p>
@@ -7989,7 +8072,7 @@
           <a:p>
             <a:fld id="{FB14FC24-E041-45E9-9A72-E5755A86890F}" type="datetime3">
               <a:rPr lang="en-US" smtClean="0"/>
-              <a:t>5 May 2026</a:t>
+              <a:t>7 July 2026</a:t>
             </a:fld>
             <a:endParaRPr lang="en-US"/>
           </a:p>
@@ -8849,7 +8932,7 @@
           <a:p>
             <a:fld id="{98A19125-94A7-4474-858C-FD9C4ABE9DDA}" type="datetime3">
               <a:rPr lang="en-US" smtClean="0"/>
-              <a:t>5 May 2026</a:t>
+              <a:t>7 July 2026</a:t>
             </a:fld>
             <a:endParaRPr lang="en-US"/>
           </a:p>
@@ -9952,7 +10035,7 @@
           <a:p>
             <a:fld id="{3BA0343D-C8D8-43CE-BB79-50DEA219DB07}" type="datetime3">
               <a:rPr lang="en-US" smtClean="0"/>
-              <a:t>5 May 2026</a:t>
+              <a:t>7 July 2026</a:t>
             </a:fld>
             <a:endParaRPr lang="en-US"/>
           </a:p>
@@ -10241,7 +10324,7 @@
           <a:p>
             <a:fld id="{453BD212-0B9F-4987-965F-AC83B2FC354F}" type="datetime3">
               <a:rPr lang="en-US" smtClean="0"/>
-              <a:t>5 May 2026</a:t>
+              <a:t>7 July 2026</a:t>
             </a:fld>
             <a:endParaRPr lang="en-US"/>
           </a:p>
@@ -10484,7 +10567,7 @@
           <a:p>
             <a:fld id="{6DDC931E-8CBE-4A3F-A034-9B6122C6DCDB}" type="datetime3">
               <a:rPr lang="en-US" smtClean="0"/>
-              <a:t>5 May 2026</a:t>
+              <a:t>7 July 2026</a:t>
             </a:fld>
             <a:endParaRPr lang="en-US"/>
           </a:p>
@@ -12250,7 +12333,7 @@
           <a:p>
             <a:fld id="{220AF9C2-5E8A-4308-AE6B-CA9B65007D0E}" type="datetime3">
               <a:rPr lang="en-US" smtClean="0"/>
-              <a:t>5 May 2026</a:t>
+              <a:t>7 July 2026</a:t>
             </a:fld>
             <a:endParaRPr lang="en-US"/>
           </a:p>
@@ -12563,7 +12646,7 @@
           <a:p>
             <a:fld id="{FF31E861-D2AF-431D-860B-DCF67C218052}" type="datetime3">
               <a:rPr lang="en-US" smtClean="0"/>
-              <a:t>5 May 2026</a:t>
+              <a:t>7 July 2026</a:t>
             </a:fld>
             <a:endParaRPr lang="en-US"/>
           </a:p>
@@ -12842,7 +12925,7 @@
           <a:p>
             <a:fld id="{D1DA25B2-AAF1-4C1F-AA38-12D5BFA7D4C8}" type="datetime3">
               <a:rPr lang="en-US" smtClean="0"/>
-              <a:t>5 May 2026</a:t>
+              <a:t>7 July 2026</a:t>
             </a:fld>
             <a:endParaRPr lang="en-US"/>
           </a:p>
@@ -13121,7 +13204,7 @@
           <a:p>
             <a:fld id="{A25C0F39-45D0-48E9-90B3-7FE8FCE561C8}" type="datetime3">
               <a:rPr lang="en-US" smtClean="0"/>
-              <a:t>5 May 2026</a:t>
+              <a:t>7 July 2026</a:t>
             </a:fld>
             <a:endParaRPr lang="en-US"/>
           </a:p>
@@ -13622,7 +13705,7 @@
           <a:p>
             <a:fld id="{9BAF1A3D-92FA-4F24-9781-74AFA516A230}" type="datetime3">
               <a:rPr lang="en-US" smtClean="0"/>
-              <a:t>5 May 2026</a:t>
+              <a:t>7 July 2026</a:t>
             </a:fld>
             <a:endParaRPr lang="en-US"/>
           </a:p>
@@ -13749,7 +13832,7 @@
           <a:p>
             <a:fld id="{5719C672-856D-4617-A693-8FE15749A9B7}" type="datetime3">
               <a:rPr lang="en-US" smtClean="0"/>
-              <a:t>5 May 2026</a:t>
+              <a:t>7 July 2026</a:t>
             </a:fld>
             <a:endParaRPr lang="en-US"/>
           </a:p>
@@ -13884,7 +13967,7 @@
           <a:p>
             <a:fld id="{5F6C764D-A39E-4C03-B161-E0BC66E8883B}" type="datetime3">
               <a:rPr lang="en-US" smtClean="0"/>
-              <a:t>5 May 2026</a:t>
+              <a:t>7 July 2026</a:t>
             </a:fld>
             <a:endParaRPr lang="en-US"/>
           </a:p>
@@ -14122,7 +14205,7 @@
           <a:p>
             <a:fld id="{6E3E33F9-20B7-4995-BE7D-165DBB597850}" type="datetime3">
               <a:rPr lang="en-US" smtClean="0"/>
-              <a:t>5 May 2026</a:t>
+              <a:t>7 July 2026</a:t>
             </a:fld>
             <a:endParaRPr lang="en-US"/>
           </a:p>
@@ -14235,7 +14318,7 @@
           <a:p>
             <a:fld id="{CD41C263-3501-4369-A962-62B6BF915CDE}" type="datetime3">
               <a:rPr lang="en-US" smtClean="0"/>
-              <a:t>5 May 2026</a:t>
+              <a:t>7 July 2026</a:t>
             </a:fld>
             <a:endParaRPr lang="en-US"/>
           </a:p>
@@ -14638,7 +14721,7 @@
           <a:p>
             <a:fld id="{B06F3EBE-B2E8-4992-9F00-9E4B44F057C0}" type="datetime3">
               <a:rPr lang="en-US" smtClean="0"/>
-              <a:t>5 May 2026</a:t>
+              <a:t>7 July 2026</a:t>
             </a:fld>
             <a:endParaRPr lang="en-US"/>
           </a:p>
@@ -14770,7 +14853,7 @@
           <a:p>
             <a:fld id="{D41656AB-D2E1-472E-8B95-0DF5C6E1D623}" type="datetime3">
               <a:rPr lang="en-US" smtClean="0"/>
-              <a:t>5 May 2026</a:t>
+              <a:t>7 July 2026</a:t>
             </a:fld>
             <a:endParaRPr lang="en-US"/>
           </a:p>
@@ -16631,7 +16714,7 @@
           <a:p>
             <a:fld id="{AD622D1A-DF83-41A8-85FF-04D90BF831D3}" type="datetime3">
               <a:rPr lang="en-US" smtClean="0"/>
-              <a:t>5 May 2026</a:t>
+              <a:t>7 July 2026</a:t>
             </a:fld>
             <a:endParaRPr lang="en-US"/>
           </a:p>
@@ -16881,7 +16964,7 @@
           <a:p>
             <a:fld id="{334F72C3-CDF3-44A8-B602-1649B1728485}" type="datetime3">
               <a:rPr lang="en-US" smtClean="0"/>
-              <a:t>5 May 2026</a:t>
+              <a:t>7 July 2026</a:t>
             </a:fld>
             <a:endParaRPr lang="en-US"/>
           </a:p>
@@ -17188,7 +17271,7 @@
           <a:p>
             <a:fld id="{1E0132BA-B5E7-4FFD-AF6C-169169D47D4A}" type="datetime3">
               <a:rPr lang="en-US" smtClean="0"/>
-              <a:t>5 May 2026</a:t>
+              <a:t>7 July 2026</a:t>
             </a:fld>
             <a:endParaRPr lang="en-US"/>
           </a:p>
@@ -17669,7 +17752,7 @@
           <a:p>
             <a:fld id="{81A30091-1C2A-4151-8D3C-D1E47A72615F}" type="datetime3">
               <a:rPr lang="en-US" smtClean="0"/>
-              <a:t>5 May 2026</a:t>
+              <a:t>7 July 2026</a:t>
             </a:fld>
             <a:endParaRPr lang="en-US"/>
           </a:p>
@@ -18306,7 +18389,7 @@
           <a:p>
             <a:fld id="{35D703CE-07B4-4C05-A488-B4566700621F}" type="datetime3">
               <a:rPr lang="en-US" smtClean="0"/>
-              <a:t>5 May 2026</a:t>
+              <a:t>7 July 2026</a:t>
             </a:fld>
             <a:endParaRPr lang="en-US"/>
           </a:p>
@@ -19364,7 +19447,7 @@
           <a:p>
             <a:fld id="{694BD61C-20BA-43AF-A21F-1DAFB3200099}" type="datetime3">
               <a:rPr lang="en-US" smtClean="0"/>
-              <a:t>5 May 2026</a:t>
+              <a:t>7 July 2026</a:t>
             </a:fld>
             <a:endParaRPr lang="en-US"/>
           </a:p>
@@ -19851,7 +19934,7 @@
           <a:p>
             <a:fld id="{CABCB1B0-B6E5-4DD1-BB55-95C076D6C0C8}" type="datetime3">
               <a:rPr lang="en-US" smtClean="0"/>
-              <a:t>5 May 2026</a:t>
+              <a:t>7 July 2026</a:t>
             </a:fld>
             <a:endParaRPr lang="en-US"/>
           </a:p>
@@ -20393,7 +20476,7 @@
           <a:p>
             <a:fld id="{7A3E0868-4E26-4CDC-8A56-D70E2D8B12FE}" type="datetime3">
               <a:rPr lang="en-US" smtClean="0"/>
-              <a:t>5 May 2026</a:t>
+              <a:t>7 July 2026</a:t>
             </a:fld>
             <a:endParaRPr lang="en-US"/>
           </a:p>
@@ -20702,7 +20785,7 @@
           <a:p>
             <a:r>
               <a:rPr lang="en-US" dirty="0"/>
-              <a:t>AI2C Course Intro</a:t>
+              <a:t>AI2C TECHNICIAN Course Intro</a:t>
             </a:r>
           </a:p>
         </p:txBody>
@@ -20792,7 +20875,7 @@
           <p:cNvPr id="2" name="Title 1">
             <a:extLst>
               <a:ext uri="{FF2B5EF4-FFF2-40B4-BE49-F238E27FC236}">
-                <a16:creationId xmlns:a16="http://schemas.microsoft.com/office/drawing/2014/main" id="{A7407C8E-BBE1-1620-CD8C-FDEE7F1AEB9F}"/>
+                <a16:creationId xmlns:a16="http://schemas.microsoft.com/office/drawing/2014/main" id="{ACF31D11-BC39-04CB-F47C-2B7646869EB7}"/>
               </a:ext>
             </a:extLst>
           </p:cNvPr>
@@ -20810,7 +20893,7 @@
           <a:p>
             <a:r>
               <a:rPr lang="en-US" dirty="0"/>
-              <a:t>Class Intros</a:t>
+              <a:t>Expectations</a:t>
             </a:r>
           </a:p>
         </p:txBody>
@@ -20820,7 +20903,7 @@
           <p:cNvPr id="3" name="Content Placeholder 2">
             <a:extLst>
               <a:ext uri="{FF2B5EF4-FFF2-40B4-BE49-F238E27FC236}">
-                <a16:creationId xmlns:a16="http://schemas.microsoft.com/office/drawing/2014/main" id="{5899F202-B34B-3F90-05A2-14991C467CF4}"/>
+                <a16:creationId xmlns:a16="http://schemas.microsoft.com/office/drawing/2014/main" id="{62E2F505-137B-1AC7-B0E0-8C0E9FF80DFC}"/>
               </a:ext>
             </a:extLst>
           </p:cNvPr>
@@ -20836,94 +20919,86 @@
           <a:bodyPr/>
           <a:lstStyle/>
           <a:p>
-            <a:pPr lvl="0"/>
-            <a:r>
-              <a:rPr lang="en-US" dirty="0">
-                <a:sym typeface="Arial"/>
-              </a:rPr>
-              <a:t> Name</a:t>
-            </a:r>
-          </a:p>
-          <a:p>
-            <a:pPr lvl="0"/>
-            <a:endParaRPr lang="en-US" dirty="0">
-              <a:sym typeface="Arial"/>
-            </a:endParaRPr>
-          </a:p>
-          <a:p>
-            <a:pPr lvl="0"/>
-            <a:r>
-              <a:rPr lang="en-US" dirty="0">
-                <a:sym typeface="Arial"/>
-              </a:rPr>
-              <a:t> Rank</a:t>
-            </a:r>
-            <a:endParaRPr lang="en-US" dirty="0"/>
-          </a:p>
-          <a:p>
-            <a:pPr lvl="0"/>
-            <a:endParaRPr lang="en-US" dirty="0">
-              <a:sym typeface="Arial"/>
-            </a:endParaRPr>
-          </a:p>
-          <a:p>
-            <a:pPr lvl="0"/>
-            <a:r>
-              <a:rPr lang="en-US" dirty="0">
-                <a:sym typeface="Arial"/>
-              </a:rPr>
-              <a:t> What you do in the Army</a:t>
-            </a:r>
-            <a:endParaRPr lang="en-US" dirty="0"/>
-          </a:p>
-          <a:p>
-            <a:pPr lvl="0"/>
-            <a:endParaRPr lang="en-US" dirty="0">
-              <a:sym typeface="Arial"/>
-            </a:endParaRPr>
-          </a:p>
-          <a:p>
-            <a:pPr lvl="0"/>
-            <a:r>
-              <a:rPr lang="en-US" dirty="0">
-                <a:sym typeface="Arial"/>
-              </a:rPr>
-              <a:t> Where you're coming from</a:t>
-            </a:r>
-            <a:endParaRPr lang="en-US" dirty="0"/>
-          </a:p>
-          <a:p>
-            <a:pPr lvl="0"/>
-            <a:endParaRPr lang="en-US" dirty="0">
-              <a:sym typeface="Arial"/>
-            </a:endParaRPr>
-          </a:p>
-          <a:p>
-            <a:pPr lvl="0"/>
-            <a:r>
-              <a:rPr lang="en-US" dirty="0">
-                <a:sym typeface="Arial"/>
-              </a:rPr>
-              <a:t> Your experience level with AI/Tech/Coding</a:t>
-            </a:r>
-            <a:endParaRPr lang="en-US" dirty="0"/>
-          </a:p>
-        </p:txBody>
-      </p:sp>
-      <p:sp>
-        <p:nvSpPr>
-          <p:cNvPr id="4" name="Content Placeholder 3">
-            <a:extLst>
-              <a:ext uri="{FF2B5EF4-FFF2-40B4-BE49-F238E27FC236}">
-                <a16:creationId xmlns:a16="http://schemas.microsoft.com/office/drawing/2014/main" id="{3E7E88B4-6DCD-526F-D991-FB7153956317}"/>
-              </a:ext>
-            </a:extLst>
-          </p:cNvPr>
-          <p:cNvSpPr>
-            <a:spLocks noGrp="1"/>
-          </p:cNvSpPr>
-          <p:nvPr>
-            <p:ph sz="half" idx="2"/>
+            <a:r>
+              <a:rPr lang="en-US" sz="2400" dirty="0"/>
+              <a:t>College courses</a:t>
+            </a:r>
+          </a:p>
+          <a:p>
+            <a:r>
+              <a:rPr lang="en-US" sz="2400" dirty="0"/>
+              <a:t>Python experience</a:t>
+            </a:r>
+          </a:p>
+          <a:p>
+            <a:pPr lvl="1"/>
+            <a:r>
+              <a:rPr lang="en-US" sz="2400" dirty="0"/>
+              <a:t>DevOps</a:t>
+            </a:r>
+          </a:p>
+          <a:p>
+            <a:pPr lvl="1"/>
+            <a:r>
+              <a:rPr lang="en-US" sz="2400" dirty="0"/>
+              <a:t>Cloud</a:t>
+            </a:r>
+          </a:p>
+          <a:p>
+            <a:r>
+              <a:rPr lang="en-US" sz="2400" dirty="0"/>
+              <a:t>Garbage in, garbage out</a:t>
+            </a:r>
+          </a:p>
+          <a:p>
+            <a:pPr lvl="1"/>
+            <a:r>
+              <a:rPr lang="en-US" sz="2400" dirty="0"/>
+              <a:t>Do the material</a:t>
+            </a:r>
+          </a:p>
+          <a:p>
+            <a:pPr lvl="1"/>
+            <a:r>
+              <a:rPr lang="en-US" sz="2400" dirty="0"/>
+              <a:t>Optional exercises</a:t>
+            </a:r>
+          </a:p>
+          <a:p>
+            <a:pPr lvl="1"/>
+            <a:r>
+              <a:rPr lang="en-US" sz="2400" dirty="0"/>
+              <a:t>Accelerated program, no spoon-feeding</a:t>
+            </a:r>
+          </a:p>
+          <a:p>
+            <a:r>
+              <a:rPr lang="en-US" sz="2400" dirty="0"/>
+              <a:t>Academic Freedom / Equality</a:t>
+            </a:r>
+          </a:p>
+          <a:p>
+            <a:r>
+              <a:rPr lang="en-US" sz="2400" dirty="0"/>
+              <a:t>What do you want out of this?</a:t>
+            </a:r>
+          </a:p>
+        </p:txBody>
+      </p:sp>
+      <p:sp>
+        <p:nvSpPr>
+          <p:cNvPr id="5" name="Date Placeholder 4">
+            <a:extLst>
+              <a:ext uri="{FF2B5EF4-FFF2-40B4-BE49-F238E27FC236}">
+                <a16:creationId xmlns:a16="http://schemas.microsoft.com/office/drawing/2014/main" id="{6BACEAE7-E57F-4F11-1616-8208D3492BA5}"/>
+              </a:ext>
+            </a:extLst>
+          </p:cNvPr>
+          <p:cNvSpPr>
+            <a:spLocks noGrp="1"/>
+          </p:cNvSpPr>
+          <p:nvPr>
+            <p:ph type="dt" sz="half" idx="10"/>
           </p:nvPr>
         </p:nvSpPr>
         <p:spPr/>
@@ -20931,34 +21006,9 @@
           <a:bodyPr/>
           <a:lstStyle/>
           <a:p>
-            <a:endParaRPr lang="en-US"/>
-          </a:p>
-        </p:txBody>
-      </p:sp>
-      <p:sp>
-        <p:nvSpPr>
-          <p:cNvPr id="5" name="Date Placeholder 4">
-            <a:extLst>
-              <a:ext uri="{FF2B5EF4-FFF2-40B4-BE49-F238E27FC236}">
-                <a16:creationId xmlns:a16="http://schemas.microsoft.com/office/drawing/2014/main" id="{3D640EFC-913A-CB78-1FFB-140336903F5C}"/>
-              </a:ext>
-            </a:extLst>
-          </p:cNvPr>
-          <p:cNvSpPr>
-            <a:spLocks noGrp="1"/>
-          </p:cNvSpPr>
-          <p:nvPr>
-            <p:ph type="dt" sz="half" idx="10"/>
-          </p:nvPr>
-        </p:nvSpPr>
-        <p:spPr/>
-        <p:txBody>
-          <a:bodyPr/>
-          <a:lstStyle/>
-          <a:p>
             <a:fld id="{334F72C3-CDF3-44A8-B602-1649B1728485}" type="datetime3">
               <a:rPr lang="en-US" smtClean="0"/>
-              <a:t>5 May 2026</a:t>
+              <a:t>7 July 2026</a:t>
             </a:fld>
             <a:endParaRPr lang="en-US"/>
           </a:p>
@@ -20969,7 +21019,7 @@
           <p:cNvPr id="6" name="Slide Number Placeholder 5">
             <a:extLst>
               <a:ext uri="{FF2B5EF4-FFF2-40B4-BE49-F238E27FC236}">
-                <a16:creationId xmlns:a16="http://schemas.microsoft.com/office/drawing/2014/main" id="{EB76AA8E-E414-56E9-5916-7185B58E62D2}"/>
+                <a16:creationId xmlns:a16="http://schemas.microsoft.com/office/drawing/2014/main" id="{F941D439-9617-EA17-D66A-F765FC76733A}"/>
               </a:ext>
             </a:extLst>
           </p:cNvPr>
@@ -20997,7 +21047,7 @@
     </p:spTree>
     <p:extLst>
       <p:ext uri="{BB962C8B-B14F-4D97-AF65-F5344CB8AC3E}">
-        <p14:creationId xmlns:p14="http://schemas.microsoft.com/office/powerpoint/2010/main" val="1247108587"/>
+        <p14:creationId xmlns:p14="http://schemas.microsoft.com/office/powerpoint/2010/main" val="1034033167"/>
       </p:ext>
     </p:extLst>
   </p:cSld>
@@ -21029,235 +21079,6 @@
           <p:cNvPr id="2" name="Title 1">
             <a:extLst>
               <a:ext uri="{FF2B5EF4-FFF2-40B4-BE49-F238E27FC236}">
-                <a16:creationId xmlns:a16="http://schemas.microsoft.com/office/drawing/2014/main" id="{ACF31D11-BC39-04CB-F47C-2B7646869EB7}"/>
-              </a:ext>
-            </a:extLst>
-          </p:cNvPr>
-          <p:cNvSpPr>
-            <a:spLocks noGrp="1"/>
-          </p:cNvSpPr>
-          <p:nvPr>
-            <p:ph type="title"/>
-          </p:nvPr>
-        </p:nvSpPr>
-        <p:spPr/>
-        <p:txBody>
-          <a:bodyPr/>
-          <a:lstStyle/>
-          <a:p>
-            <a:r>
-              <a:rPr lang="en-US" dirty="0"/>
-              <a:t>Expectations</a:t>
-            </a:r>
-          </a:p>
-        </p:txBody>
-      </p:sp>
-      <p:sp>
-        <p:nvSpPr>
-          <p:cNvPr id="3" name="Content Placeholder 2">
-            <a:extLst>
-              <a:ext uri="{FF2B5EF4-FFF2-40B4-BE49-F238E27FC236}">
-                <a16:creationId xmlns:a16="http://schemas.microsoft.com/office/drawing/2014/main" id="{62E2F505-137B-1AC7-B0E0-8C0E9FF80DFC}"/>
-              </a:ext>
-            </a:extLst>
-          </p:cNvPr>
-          <p:cNvSpPr>
-            <a:spLocks noGrp="1"/>
-          </p:cNvSpPr>
-          <p:nvPr>
-            <p:ph sz="half" idx="1"/>
-          </p:nvPr>
-        </p:nvSpPr>
-        <p:spPr/>
-        <p:txBody>
-          <a:bodyPr/>
-          <a:lstStyle/>
-          <a:p>
-            <a:r>
-              <a:rPr lang="en-US" dirty="0"/>
-              <a:t>College courses</a:t>
-            </a:r>
-          </a:p>
-          <a:p>
-            <a:r>
-              <a:rPr lang="en-US" dirty="0"/>
-              <a:t>Python experience</a:t>
-            </a:r>
-          </a:p>
-          <a:p>
-            <a:pPr lvl="1"/>
-            <a:r>
-              <a:rPr lang="en-US" dirty="0"/>
-              <a:t>DevOps</a:t>
-            </a:r>
-          </a:p>
-          <a:p>
-            <a:pPr lvl="1"/>
-            <a:r>
-              <a:rPr lang="en-US" dirty="0"/>
-              <a:t>Cloud</a:t>
-            </a:r>
-          </a:p>
-          <a:p>
-            <a:r>
-              <a:rPr lang="en-US" dirty="0"/>
-              <a:t>Garbage in, garbage out</a:t>
-            </a:r>
-          </a:p>
-          <a:p>
-            <a:pPr lvl="1"/>
-            <a:r>
-              <a:rPr lang="en-US" dirty="0"/>
-              <a:t>Do the material</a:t>
-            </a:r>
-          </a:p>
-          <a:p>
-            <a:pPr lvl="1"/>
-            <a:r>
-              <a:rPr lang="en-US" dirty="0"/>
-              <a:t>Optional exercises</a:t>
-            </a:r>
-          </a:p>
-          <a:p>
-            <a:pPr lvl="1"/>
-            <a:r>
-              <a:rPr lang="en-US" dirty="0"/>
-              <a:t>Accelerated program, no spoon-feeding</a:t>
-            </a:r>
-          </a:p>
-          <a:p>
-            <a:r>
-              <a:rPr lang="en-US" dirty="0"/>
-              <a:t>Academic Freedom / Equality</a:t>
-            </a:r>
-          </a:p>
-          <a:p>
-            <a:r>
-              <a:rPr lang="en-US" dirty="0"/>
-              <a:t>What do you want out of this?</a:t>
-            </a:r>
-          </a:p>
-        </p:txBody>
-      </p:sp>
-      <p:sp>
-        <p:nvSpPr>
-          <p:cNvPr id="4" name="Content Placeholder 3">
-            <a:extLst>
-              <a:ext uri="{FF2B5EF4-FFF2-40B4-BE49-F238E27FC236}">
-                <a16:creationId xmlns:a16="http://schemas.microsoft.com/office/drawing/2014/main" id="{6F476D62-E1B2-E345-5E34-1114082718DA}"/>
-              </a:ext>
-            </a:extLst>
-          </p:cNvPr>
-          <p:cNvSpPr>
-            <a:spLocks noGrp="1"/>
-          </p:cNvSpPr>
-          <p:nvPr>
-            <p:ph sz="half" idx="2"/>
-          </p:nvPr>
-        </p:nvSpPr>
-        <p:spPr/>
-        <p:txBody>
-          <a:bodyPr/>
-          <a:lstStyle/>
-          <a:p>
-            <a:endParaRPr lang="en-US"/>
-          </a:p>
-        </p:txBody>
-      </p:sp>
-      <p:sp>
-        <p:nvSpPr>
-          <p:cNvPr id="5" name="Date Placeholder 4">
-            <a:extLst>
-              <a:ext uri="{FF2B5EF4-FFF2-40B4-BE49-F238E27FC236}">
-                <a16:creationId xmlns:a16="http://schemas.microsoft.com/office/drawing/2014/main" id="{6BACEAE7-E57F-4F11-1616-8208D3492BA5}"/>
-              </a:ext>
-            </a:extLst>
-          </p:cNvPr>
-          <p:cNvSpPr>
-            <a:spLocks noGrp="1"/>
-          </p:cNvSpPr>
-          <p:nvPr>
-            <p:ph type="dt" sz="half" idx="10"/>
-          </p:nvPr>
-        </p:nvSpPr>
-        <p:spPr/>
-        <p:txBody>
-          <a:bodyPr/>
-          <a:lstStyle/>
-          <a:p>
-            <a:fld id="{334F72C3-CDF3-44A8-B602-1649B1728485}" type="datetime3">
-              <a:rPr lang="en-US" smtClean="0"/>
-              <a:t>5 May 2026</a:t>
-            </a:fld>
-            <a:endParaRPr lang="en-US"/>
-          </a:p>
-        </p:txBody>
-      </p:sp>
-      <p:sp>
-        <p:nvSpPr>
-          <p:cNvPr id="6" name="Slide Number Placeholder 5">
-            <a:extLst>
-              <a:ext uri="{FF2B5EF4-FFF2-40B4-BE49-F238E27FC236}">
-                <a16:creationId xmlns:a16="http://schemas.microsoft.com/office/drawing/2014/main" id="{F941D439-9617-EA17-D66A-F765FC76733A}"/>
-              </a:ext>
-            </a:extLst>
-          </p:cNvPr>
-          <p:cNvSpPr>
-            <a:spLocks noGrp="1"/>
-          </p:cNvSpPr>
-          <p:nvPr>
-            <p:ph type="sldNum" sz="quarter" idx="11"/>
-          </p:nvPr>
-        </p:nvSpPr>
-        <p:spPr/>
-        <p:txBody>
-          <a:bodyPr/>
-          <a:lstStyle/>
-          <a:p>
-            <a:fld id="{64E5BE4B-2FBF-4174-9E62-85FAD1CB43A6}" type="slidenum">
-              <a:rPr lang="en-US" smtClean="0"/>
-              <a:pPr/>
-              <a:t>11</a:t>
-            </a:fld>
-            <a:endParaRPr lang="en-US"/>
-          </a:p>
-        </p:txBody>
-      </p:sp>
-    </p:spTree>
-    <p:extLst>
-      <p:ext uri="{BB962C8B-B14F-4D97-AF65-F5344CB8AC3E}">
-        <p14:creationId xmlns:p14="http://schemas.microsoft.com/office/powerpoint/2010/main" val="1034033167"/>
-      </p:ext>
-    </p:extLst>
-  </p:cSld>
-  <p:clrMapOvr>
-    <a:masterClrMapping/>
-  </p:clrMapOvr>
-</p:sld>
-</file>
-
-<file path=ppt/slides/slide12.xml><?xml version="1.0" encoding="utf-8"?>
-<p:sld xmlns:a="http://schemas.openxmlformats.org/drawingml/2006/main" xmlns:r="http://schemas.openxmlformats.org/officeDocument/2006/relationships" xmlns:p="http://schemas.openxmlformats.org/presentationml/2006/main">
-  <p:cSld>
-    <p:spTree>
-      <p:nvGrpSpPr>
-        <p:cNvPr id="1" name=""/>
-        <p:cNvGrpSpPr/>
-        <p:nvPr/>
-      </p:nvGrpSpPr>
-      <p:grpSpPr>
-        <a:xfrm>
-          <a:off x="0" y="0"/>
-          <a:ext cx="0" cy="0"/>
-          <a:chOff x="0" y="0"/>
-          <a:chExt cx="0" cy="0"/>
-        </a:xfrm>
-      </p:grpSpPr>
-      <p:sp>
-        <p:nvSpPr>
-          <p:cNvPr id="2" name="Title 1">
-            <a:extLst>
-              <a:ext uri="{FF2B5EF4-FFF2-40B4-BE49-F238E27FC236}">
                 <a16:creationId xmlns:a16="http://schemas.microsoft.com/office/drawing/2014/main" id="{BDF19F20-6347-584A-BCA2-BAE9AC8DADD7}"/>
               </a:ext>
             </a:extLst>
@@ -21336,7 +21157,7 @@
           <a:p>
             <a:fld id="{334F72C3-CDF3-44A8-B602-1649B1728485}" type="datetime3">
               <a:rPr lang="en-US" smtClean="0"/>
-              <a:t>5 May 2026</a:t>
+              <a:t>7 July 2026</a:t>
             </a:fld>
             <a:endParaRPr lang="en-US"/>
           </a:p>
@@ -21366,7 +21187,7 @@
             <a:fld id="{64E5BE4B-2FBF-4174-9E62-85FAD1CB43A6}" type="slidenum">
               <a:rPr lang="en-US" smtClean="0"/>
               <a:pPr/>
-              <a:t>12</a:t>
+              <a:t>11</a:t>
             </a:fld>
             <a:endParaRPr lang="en-US"/>
           </a:p>
@@ -21603,7 +21424,7 @@
 </p:sld>
 </file>
 
-<file path=ppt/slides/slide13.xml><?xml version="1.0" encoding="utf-8"?>
+<file path=ppt/slides/slide12.xml><?xml version="1.0" encoding="utf-8"?>
 <p:sld xmlns:a="http://schemas.openxmlformats.org/drawingml/2006/main" xmlns:r="http://schemas.openxmlformats.org/officeDocument/2006/relationships" xmlns:p="http://schemas.openxmlformats.org/presentationml/2006/main">
   <p:cSld>
     <p:spTree>
@@ -21671,7 +21492,7 @@
           <a:p>
             <a:fld id="{334F72C3-CDF3-44A8-B602-1649B1728485}" type="datetime3">
               <a:rPr lang="en-US" smtClean="0"/>
-              <a:t>5 May 2026</a:t>
+              <a:t>7 July 2026</a:t>
             </a:fld>
             <a:endParaRPr lang="en-US"/>
           </a:p>
@@ -21701,7 +21522,7 @@
             <a:fld id="{64E5BE4B-2FBF-4174-9E62-85FAD1CB43A6}" type="slidenum">
               <a:rPr lang="en-US" smtClean="0"/>
               <a:pPr/>
-              <a:t>13</a:t>
+              <a:t>12</a:t>
             </a:fld>
             <a:endParaRPr lang="en-US"/>
           </a:p>
@@ -21753,7 +21574,7 @@
 </p:sld>
 </file>
 
-<file path=ppt/slides/slide14.xml><?xml version="1.0" encoding="utf-8"?>
+<file path=ppt/slides/slide13.xml><?xml version="1.0" encoding="utf-8"?>
 <p:sld xmlns:a="http://schemas.openxmlformats.org/drawingml/2006/main" xmlns:r="http://schemas.openxmlformats.org/officeDocument/2006/relationships" xmlns:p="http://schemas.openxmlformats.org/presentationml/2006/main">
   <p:cSld>
     <p:spTree>
@@ -21827,7 +21648,7 @@
           <a:p>
             <a:fld id="{AD622D1A-DF83-41A8-85FF-04D90BF831D3}" type="datetime3">
               <a:rPr lang="en-US" smtClean="0"/>
-              <a:t>5 May 2026</a:t>
+              <a:t>7 July 2026</a:t>
             </a:fld>
             <a:endParaRPr lang="en-US"/>
           </a:p>
@@ -21857,7 +21678,7 @@
             <a:fld id="{64E5BE4B-2FBF-4174-9E62-85FAD1CB43A6}" type="slidenum">
               <a:rPr lang="en-US" smtClean="0"/>
               <a:pPr/>
-              <a:t>14</a:t>
+              <a:t>13</a:t>
             </a:fld>
             <a:endParaRPr lang="en-US"/>
           </a:p>
@@ -21895,10 +21716,10 @@
       </p:grpSpPr>
       <p:sp>
         <p:nvSpPr>
-          <p:cNvPr id="2" name="Title 1">
-            <a:extLst>
-              <a:ext uri="{FF2B5EF4-FFF2-40B4-BE49-F238E27FC236}">
-                <a16:creationId xmlns:a16="http://schemas.microsoft.com/office/drawing/2014/main" id="{6C3B6654-3FFC-A3A1-9164-25CDC978D21C}"/>
+          <p:cNvPr id="17" name="Title 16">
+            <a:extLst>
+              <a:ext uri="{FF2B5EF4-FFF2-40B4-BE49-F238E27FC236}">
+                <a16:creationId xmlns:a16="http://schemas.microsoft.com/office/drawing/2014/main" id="{C74CE5AE-5F74-8B53-9A6A-107510D6BA66}"/>
               </a:ext>
             </a:extLst>
           </p:cNvPr>
@@ -21916,17 +21737,17 @@
           <a:p>
             <a:r>
               <a:rPr lang="en-US" dirty="0"/>
-              <a:t>Agenda</a:t>
-            </a:r>
-          </a:p>
-        </p:txBody>
-      </p:sp>
-      <p:sp>
-        <p:nvSpPr>
-          <p:cNvPr id="3" name="Content Placeholder 2">
-            <a:extLst>
-              <a:ext uri="{FF2B5EF4-FFF2-40B4-BE49-F238E27FC236}">
-                <a16:creationId xmlns:a16="http://schemas.microsoft.com/office/drawing/2014/main" id="{D58333B6-F4A9-71BB-5470-0808A0EFC7B1}"/>
+              <a:t>Technician Course Structure</a:t>
+            </a:r>
+          </a:p>
+        </p:txBody>
+      </p:sp>
+      <p:sp>
+        <p:nvSpPr>
+          <p:cNvPr id="18" name="Content Placeholder 17">
+            <a:extLst>
+              <a:ext uri="{FF2B5EF4-FFF2-40B4-BE49-F238E27FC236}">
+                <a16:creationId xmlns:a16="http://schemas.microsoft.com/office/drawing/2014/main" id="{AC1A4853-2BE5-324F-194E-A65A4FDE244A}"/>
               </a:ext>
             </a:extLst>
           </p:cNvPr>
@@ -21944,26 +21765,29 @@
           <a:p>
             <a:r>
               <a:rPr lang="en-US" dirty="0"/>
-              <a:t>Scheduling</a:t>
+              <a:t>Summer prep (Jul – Aug)</a:t>
             </a:r>
           </a:p>
           <a:p>
             <a:r>
               <a:rPr lang="en-US" dirty="0"/>
-              <a:t>Introductions</a:t>
-            </a:r>
-          </a:p>
-          <a:p>
-            <a:endParaRPr lang="en-US" dirty="0"/>
-          </a:p>
-        </p:txBody>
-      </p:sp>
-      <p:sp>
-        <p:nvSpPr>
-          <p:cNvPr id="4" name="Date Placeholder 3">
-            <a:extLst>
-              <a:ext uri="{FF2B5EF4-FFF2-40B4-BE49-F238E27FC236}">
-                <a16:creationId xmlns:a16="http://schemas.microsoft.com/office/drawing/2014/main" id="{1F015155-18C3-DAA6-FC60-5AD4DC67B1D1}"/>
+              <a:t>CMU course (Aug – May)</a:t>
+            </a:r>
+          </a:p>
+          <a:p>
+            <a:r>
+              <a:rPr lang="en-US" dirty="0"/>
+              <a:t>AI2C specific training (May – Jun, TBD)</a:t>
+            </a:r>
+          </a:p>
+        </p:txBody>
+      </p:sp>
+      <p:sp>
+        <p:nvSpPr>
+          <p:cNvPr id="2" name="Date Placeholder 1">
+            <a:extLst>
+              <a:ext uri="{FF2B5EF4-FFF2-40B4-BE49-F238E27FC236}">
+                <a16:creationId xmlns:a16="http://schemas.microsoft.com/office/drawing/2014/main" id="{C9476938-33C4-D69D-C040-76FBCAEE7623}"/>
               </a:ext>
             </a:extLst>
           </p:cNvPr>
@@ -21979,9 +21803,9 @@
           <a:bodyPr/>
           <a:lstStyle/>
           <a:p>
-            <a:fld id="{AD622D1A-DF83-41A8-85FF-04D90BF831D3}" type="datetime3">
+            <a:fld id="{6DDC931E-8CBE-4A3F-A034-9B6122C6DCDB}" type="datetime3">
               <a:rPr lang="en-US" smtClean="0"/>
-              <a:t>5 May 2026</a:t>
+              <a:t>7 July 2026</a:t>
             </a:fld>
             <a:endParaRPr lang="en-US"/>
           </a:p>
@@ -21989,10 +21813,10 @@
       </p:sp>
       <p:sp>
         <p:nvSpPr>
-          <p:cNvPr id="5" name="Slide Number Placeholder 4">
-            <a:extLst>
-              <a:ext uri="{FF2B5EF4-FFF2-40B4-BE49-F238E27FC236}">
-                <a16:creationId xmlns:a16="http://schemas.microsoft.com/office/drawing/2014/main" id="{36C0974A-437A-BFDF-9835-2ABB5CC47DC4}"/>
+          <p:cNvPr id="3" name="Slide Number Placeholder 2">
+            <a:extLst>
+              <a:ext uri="{FF2B5EF4-FFF2-40B4-BE49-F238E27FC236}">
+                <a16:creationId xmlns:a16="http://schemas.microsoft.com/office/drawing/2014/main" id="{998FC7C2-68FB-353B-BACE-D9C68FBC75D2}"/>
               </a:ext>
             </a:extLst>
           </p:cNvPr>
@@ -22020,7 +21844,7 @@
     </p:spTree>
     <p:extLst>
       <p:ext uri="{BB962C8B-B14F-4D97-AF65-F5344CB8AC3E}">
-        <p14:creationId xmlns:p14="http://schemas.microsoft.com/office/powerpoint/2010/main" val="3710859548"/>
+        <p14:creationId xmlns:p14="http://schemas.microsoft.com/office/powerpoint/2010/main" val="2316933957"/>
       </p:ext>
     </p:extLst>
   </p:cSld>
@@ -22049,10 +21873,10 @@
       </p:grpSpPr>
       <p:sp>
         <p:nvSpPr>
-          <p:cNvPr id="17" name="Title 16">
-            <a:extLst>
-              <a:ext uri="{FF2B5EF4-FFF2-40B4-BE49-F238E27FC236}">
-                <a16:creationId xmlns:a16="http://schemas.microsoft.com/office/drawing/2014/main" id="{C74CE5AE-5F74-8B53-9A6A-107510D6BA66}"/>
+          <p:cNvPr id="2" name="Title 1">
+            <a:extLst>
+              <a:ext uri="{FF2B5EF4-FFF2-40B4-BE49-F238E27FC236}">
+                <a16:creationId xmlns:a16="http://schemas.microsoft.com/office/drawing/2014/main" id="{365E2E2A-93CC-228B-5D5D-F248940CF507}"/>
               </a:ext>
             </a:extLst>
           </p:cNvPr>
@@ -22070,25 +21894,25 @@
           <a:p>
             <a:r>
               <a:rPr lang="en-US" dirty="0"/>
-              <a:t>Course Structure</a:t>
-            </a:r>
-          </a:p>
-        </p:txBody>
-      </p:sp>
-      <p:sp>
-        <p:nvSpPr>
-          <p:cNvPr id="18" name="Content Placeholder 17">
-            <a:extLst>
-              <a:ext uri="{FF2B5EF4-FFF2-40B4-BE49-F238E27FC236}">
-                <a16:creationId xmlns:a16="http://schemas.microsoft.com/office/drawing/2014/main" id="{AC1A4853-2BE5-324F-194E-A65A4FDE244A}"/>
-              </a:ext>
-            </a:extLst>
-          </p:cNvPr>
-          <p:cNvSpPr>
-            <a:spLocks noGrp="1"/>
-          </p:cNvSpPr>
-          <p:nvPr>
-            <p:ph idx="1"/>
+              <a:t>Summer Schedule</a:t>
+            </a:r>
+          </a:p>
+        </p:txBody>
+      </p:sp>
+      <p:sp>
+        <p:nvSpPr>
+          <p:cNvPr id="5" name="Date Placeholder 4">
+            <a:extLst>
+              <a:ext uri="{FF2B5EF4-FFF2-40B4-BE49-F238E27FC236}">
+                <a16:creationId xmlns:a16="http://schemas.microsoft.com/office/drawing/2014/main" id="{47555EF5-7236-389B-A096-020C6BD2B4B0}"/>
+              </a:ext>
+            </a:extLst>
+          </p:cNvPr>
+          <p:cNvSpPr>
+            <a:spLocks noGrp="1"/>
+          </p:cNvSpPr>
+          <p:nvPr>
+            <p:ph type="dt" sz="half" idx="10"/>
           </p:nvPr>
         </p:nvSpPr>
         <p:spPr/>
@@ -22096,49 +21920,9 @@
           <a:bodyPr/>
           <a:lstStyle/>
           <a:p>
-            <a:r>
-              <a:rPr lang="en-US" dirty="0"/>
-              <a:t>Summer prep (Jul – Aug)</a:t>
-            </a:r>
-          </a:p>
-          <a:p>
-            <a:r>
-              <a:rPr lang="en-US" dirty="0"/>
-              <a:t>CMU course (Aug – May)</a:t>
-            </a:r>
-          </a:p>
-          <a:p>
-            <a:r>
-              <a:rPr lang="en-US" dirty="0"/>
-              <a:t>Factory specifics (May – Jun, TBD)</a:t>
-            </a:r>
-          </a:p>
-        </p:txBody>
-      </p:sp>
-      <p:sp>
-        <p:nvSpPr>
-          <p:cNvPr id="2" name="Date Placeholder 1">
-            <a:extLst>
-              <a:ext uri="{FF2B5EF4-FFF2-40B4-BE49-F238E27FC236}">
-                <a16:creationId xmlns:a16="http://schemas.microsoft.com/office/drawing/2014/main" id="{C9476938-33C4-D69D-C040-76FBCAEE7623}"/>
-              </a:ext>
-            </a:extLst>
-          </p:cNvPr>
-          <p:cNvSpPr>
-            <a:spLocks noGrp="1"/>
-          </p:cNvSpPr>
-          <p:nvPr>
-            <p:ph type="dt" sz="half" idx="10"/>
-          </p:nvPr>
-        </p:nvSpPr>
-        <p:spPr/>
-        <p:txBody>
-          <a:bodyPr/>
-          <a:lstStyle/>
-          <a:p>
-            <a:fld id="{6DDC931E-8CBE-4A3F-A034-9B6122C6DCDB}" type="datetime3">
+            <a:fld id="{334F72C3-CDF3-44A8-B602-1649B1728485}" type="datetime3">
               <a:rPr lang="en-US" smtClean="0"/>
-              <a:t>5 May 2026</a:t>
+              <a:t>7 July 2026</a:t>
             </a:fld>
             <a:endParaRPr lang="en-US"/>
           </a:p>
@@ -22146,10 +21930,10 @@
       </p:sp>
       <p:sp>
         <p:nvSpPr>
-          <p:cNvPr id="3" name="Slide Number Placeholder 2">
-            <a:extLst>
-              <a:ext uri="{FF2B5EF4-FFF2-40B4-BE49-F238E27FC236}">
-                <a16:creationId xmlns:a16="http://schemas.microsoft.com/office/drawing/2014/main" id="{998FC7C2-68FB-353B-BACE-D9C68FBC75D2}"/>
+          <p:cNvPr id="6" name="Slide Number Placeholder 5">
+            <a:extLst>
+              <a:ext uri="{FF2B5EF4-FFF2-40B4-BE49-F238E27FC236}">
+                <a16:creationId xmlns:a16="http://schemas.microsoft.com/office/drawing/2014/main" id="{F3A2635F-9AA6-9FE3-2A0C-E6C297FC6617}"/>
               </a:ext>
             </a:extLst>
           </p:cNvPr>
@@ -22174,10 +21958,40 @@
           </a:p>
         </p:txBody>
       </p:sp>
+      <p:pic>
+        <p:nvPicPr>
+          <p:cNvPr id="12" name="Picture 11">
+            <a:extLst>
+              <a:ext uri="{FF2B5EF4-FFF2-40B4-BE49-F238E27FC236}">
+                <a16:creationId xmlns:a16="http://schemas.microsoft.com/office/drawing/2014/main" id="{6AED071E-DED9-5DA1-6FE7-321B92ACB454}"/>
+              </a:ext>
+            </a:extLst>
+          </p:cNvPr>
+          <p:cNvPicPr>
+            <a:picLocks noChangeAspect="1"/>
+          </p:cNvPicPr>
+          <p:nvPr/>
+        </p:nvPicPr>
+        <p:blipFill>
+          <a:blip r:embed="rId3"/>
+          <a:stretch>
+            <a:fillRect/>
+          </a:stretch>
+        </p:blipFill>
+        <p:spPr>
+          <a:xfrm>
+            <a:off x="318946" y="1180086"/>
+            <a:ext cx="11125763" cy="5094254"/>
+          </a:xfrm>
+          <a:prstGeom prst="rect">
+            <a:avLst/>
+          </a:prstGeom>
+        </p:spPr>
+      </p:pic>
     </p:spTree>
     <p:extLst>
       <p:ext uri="{BB962C8B-B14F-4D97-AF65-F5344CB8AC3E}">
-        <p14:creationId xmlns:p14="http://schemas.microsoft.com/office/powerpoint/2010/main" val="2316933957"/>
+        <p14:creationId xmlns:p14="http://schemas.microsoft.com/office/powerpoint/2010/main" val="818344109"/>
       </p:ext>
     </p:extLst>
   </p:cSld>
@@ -22206,10 +22020,10 @@
       </p:grpSpPr>
       <p:sp>
         <p:nvSpPr>
-          <p:cNvPr id="2" name="Title 1">
-            <a:extLst>
-              <a:ext uri="{FF2B5EF4-FFF2-40B4-BE49-F238E27FC236}">
-                <a16:creationId xmlns:a16="http://schemas.microsoft.com/office/drawing/2014/main" id="{365E2E2A-93CC-228B-5D5D-F248940CF507}"/>
+          <p:cNvPr id="6" name="Title 5">
+            <a:extLst>
+              <a:ext uri="{FF2B5EF4-FFF2-40B4-BE49-F238E27FC236}">
+                <a16:creationId xmlns:a16="http://schemas.microsoft.com/office/drawing/2014/main" id="{69E56E2B-F7F0-66BD-FE9C-392C14379B8C}"/>
               </a:ext>
             </a:extLst>
           </p:cNvPr>
@@ -22227,57 +22041,25 @@
           <a:p>
             <a:r>
               <a:rPr lang="en-US" dirty="0"/>
-              <a:t>Summer Schedule</a:t>
-            </a:r>
-          </a:p>
-        </p:txBody>
-      </p:sp>
-      <p:pic>
-        <p:nvPicPr>
-          <p:cNvPr id="11" name="Content Placeholder 10">
-            <a:extLst>
-              <a:ext uri="{FF2B5EF4-FFF2-40B4-BE49-F238E27FC236}">
-                <a16:creationId xmlns:a16="http://schemas.microsoft.com/office/drawing/2014/main" id="{32D5C26D-6EF8-167E-E837-90FED81D1704}"/>
-              </a:ext>
-            </a:extLst>
-          </p:cNvPr>
-          <p:cNvPicPr>
-            <a:picLocks noGrp="1" noChangeAspect="1"/>
-          </p:cNvPicPr>
-          <p:nvPr>
-            <p:ph idx="1"/>
-          </p:nvPr>
-        </p:nvPicPr>
-        <p:blipFill>
-          <a:blip r:embed="rId2"/>
-          <a:stretch>
-            <a:fillRect/>
-          </a:stretch>
-        </p:blipFill>
-        <p:spPr>
-          <a:xfrm>
-            <a:off x="302536" y="1325881"/>
-            <a:ext cx="11586927" cy="4746056"/>
-          </a:xfrm>
-          <a:prstGeom prst="rect">
-            <a:avLst/>
-          </a:prstGeom>
-        </p:spPr>
-      </p:pic>
-      <p:sp>
-        <p:nvSpPr>
-          <p:cNvPr id="5" name="Date Placeholder 4">
-            <a:extLst>
-              <a:ext uri="{FF2B5EF4-FFF2-40B4-BE49-F238E27FC236}">
-                <a16:creationId xmlns:a16="http://schemas.microsoft.com/office/drawing/2014/main" id="{47555EF5-7236-389B-A096-020C6BD2B4B0}"/>
-              </a:ext>
-            </a:extLst>
-          </p:cNvPr>
-          <p:cNvSpPr>
-            <a:spLocks noGrp="1"/>
-          </p:cNvSpPr>
-          <p:nvPr>
-            <p:ph type="dt" sz="half" idx="10"/>
+              <a:t>SUMMER Daily Schedule</a:t>
+            </a:r>
+          </a:p>
+        </p:txBody>
+      </p:sp>
+      <p:sp>
+        <p:nvSpPr>
+          <p:cNvPr id="7" name="Content Placeholder 6">
+            <a:extLst>
+              <a:ext uri="{FF2B5EF4-FFF2-40B4-BE49-F238E27FC236}">
+                <a16:creationId xmlns:a16="http://schemas.microsoft.com/office/drawing/2014/main" id="{27ED88B9-3357-EC07-CBC8-2BC307869C64}"/>
+              </a:ext>
+            </a:extLst>
+          </p:cNvPr>
+          <p:cNvSpPr>
+            <a:spLocks noGrp="1"/>
+          </p:cNvSpPr>
+          <p:nvPr>
+            <p:ph sz="half" idx="1"/>
           </p:nvPr>
         </p:nvSpPr>
         <p:spPr/>
@@ -22285,9 +22067,46 @@
           <a:bodyPr/>
           <a:lstStyle/>
           <a:p>
-            <a:fld id="{334F72C3-CDF3-44A8-B602-1649B1728485}" type="datetime3">
+            <a:r>
+              <a:rPr lang="en-US" sz="2400" dirty="0"/>
+              <a:t>1000 – UTC – Morning class</a:t>
+            </a:r>
+          </a:p>
+          <a:p>
+            <a:r>
+              <a:rPr lang="en-US" sz="2400" dirty="0"/>
+              <a:t>1300 – UTC – Afternoon class</a:t>
+            </a:r>
+          </a:p>
+          <a:p>
+            <a:endParaRPr lang="en-US" dirty="0"/>
+          </a:p>
+        </p:txBody>
+      </p:sp>
+      <p:sp>
+        <p:nvSpPr>
+          <p:cNvPr id="4" name="Date Placeholder 3">
+            <a:extLst>
+              <a:ext uri="{FF2B5EF4-FFF2-40B4-BE49-F238E27FC236}">
+                <a16:creationId xmlns:a16="http://schemas.microsoft.com/office/drawing/2014/main" id="{C9AE2388-31A1-DD2E-2E5F-A5BD9A217891}"/>
+              </a:ext>
+            </a:extLst>
+          </p:cNvPr>
+          <p:cNvSpPr>
+            <a:spLocks noGrp="1"/>
+          </p:cNvSpPr>
+          <p:nvPr>
+            <p:ph type="dt" sz="half" idx="10"/>
+          </p:nvPr>
+        </p:nvSpPr>
+        <p:spPr/>
+        <p:txBody>
+          <a:bodyPr/>
+          <a:lstStyle/>
+          <a:p>
+            <a:fld id="{AD622D1A-DF83-41A8-85FF-04D90BF831D3}" type="datetime3">
               <a:rPr lang="en-US" smtClean="0"/>
-              <a:t>5 May 2026</a:t>
+              <a:t>7 July 2026</a:t>
             </a:fld>
             <a:endParaRPr lang="en-US"/>
           </a:p>
@@ -22295,10 +22114,10 @@
       </p:sp>
       <p:sp>
         <p:nvSpPr>
-          <p:cNvPr id="6" name="Slide Number Placeholder 5">
-            <a:extLst>
-              <a:ext uri="{FF2B5EF4-FFF2-40B4-BE49-F238E27FC236}">
-                <a16:creationId xmlns:a16="http://schemas.microsoft.com/office/drawing/2014/main" id="{F3A2635F-9AA6-9FE3-2A0C-E6C297FC6617}"/>
+          <p:cNvPr id="5" name="Slide Number Placeholder 4">
+            <a:extLst>
+              <a:ext uri="{FF2B5EF4-FFF2-40B4-BE49-F238E27FC236}">
+                <a16:creationId xmlns:a16="http://schemas.microsoft.com/office/drawing/2014/main" id="{94E1A057-81B7-19AA-B0FD-7BF9FCA712CF}"/>
               </a:ext>
             </a:extLst>
           </p:cNvPr>
@@ -22326,7 +22145,7 @@
     </p:spTree>
     <p:extLst>
       <p:ext uri="{BB962C8B-B14F-4D97-AF65-F5344CB8AC3E}">
-        <p14:creationId xmlns:p14="http://schemas.microsoft.com/office/powerpoint/2010/main" val="818344109"/>
+        <p14:creationId xmlns:p14="http://schemas.microsoft.com/office/powerpoint/2010/main" val="1685140285"/>
       </p:ext>
     </p:extLst>
   </p:cSld>
@@ -22383,18 +22202,18 @@
       </p:sp>
       <p:sp>
         <p:nvSpPr>
-          <p:cNvPr id="3" name="Content Placeholder 2">
-            <a:extLst>
-              <a:ext uri="{FF2B5EF4-FFF2-40B4-BE49-F238E27FC236}">
-                <a16:creationId xmlns:a16="http://schemas.microsoft.com/office/drawing/2014/main" id="{7E4B01E5-85B2-23DD-3DEC-95B976A7F3CE}"/>
-              </a:ext>
-            </a:extLst>
-          </p:cNvPr>
-          <p:cNvSpPr>
-            <a:spLocks noGrp="1"/>
-          </p:cNvSpPr>
-          <p:nvPr>
-            <p:ph sz="half" idx="1"/>
+          <p:cNvPr id="5" name="Date Placeholder 4">
+            <a:extLst>
+              <a:ext uri="{FF2B5EF4-FFF2-40B4-BE49-F238E27FC236}">
+                <a16:creationId xmlns:a16="http://schemas.microsoft.com/office/drawing/2014/main" id="{224AF8C8-16DF-8237-872C-03B4631471FB}"/>
+              </a:ext>
+            </a:extLst>
+          </p:cNvPr>
+          <p:cNvSpPr>
+            <a:spLocks noGrp="1"/>
+          </p:cNvSpPr>
+          <p:nvPr>
+            <p:ph type="dt" sz="half" idx="10"/>
           </p:nvPr>
         </p:nvSpPr>
         <p:spPr/>
@@ -22402,59 +22221,9 @@
           <a:bodyPr/>
           <a:lstStyle/>
           <a:p>
-            <a:endParaRPr lang="en-US"/>
-          </a:p>
-        </p:txBody>
-      </p:sp>
-      <p:sp>
-        <p:nvSpPr>
-          <p:cNvPr id="4" name="Content Placeholder 3">
-            <a:extLst>
-              <a:ext uri="{FF2B5EF4-FFF2-40B4-BE49-F238E27FC236}">
-                <a16:creationId xmlns:a16="http://schemas.microsoft.com/office/drawing/2014/main" id="{87221241-C0DA-590C-8635-E7CC002EE22B}"/>
-              </a:ext>
-            </a:extLst>
-          </p:cNvPr>
-          <p:cNvSpPr>
-            <a:spLocks noGrp="1"/>
-          </p:cNvSpPr>
-          <p:nvPr>
-            <p:ph sz="half" idx="2"/>
-          </p:nvPr>
-        </p:nvSpPr>
-        <p:spPr/>
-        <p:txBody>
-          <a:bodyPr/>
-          <a:lstStyle/>
-          <a:p>
-            <a:endParaRPr lang="en-US"/>
-          </a:p>
-        </p:txBody>
-      </p:sp>
-      <p:sp>
-        <p:nvSpPr>
-          <p:cNvPr id="5" name="Date Placeholder 4">
-            <a:extLst>
-              <a:ext uri="{FF2B5EF4-FFF2-40B4-BE49-F238E27FC236}">
-                <a16:creationId xmlns:a16="http://schemas.microsoft.com/office/drawing/2014/main" id="{224AF8C8-16DF-8237-872C-03B4631471FB}"/>
-              </a:ext>
-            </a:extLst>
-          </p:cNvPr>
-          <p:cNvSpPr>
-            <a:spLocks noGrp="1"/>
-          </p:cNvSpPr>
-          <p:nvPr>
-            <p:ph type="dt" sz="half" idx="10"/>
-          </p:nvPr>
-        </p:nvSpPr>
-        <p:spPr/>
-        <p:txBody>
-          <a:bodyPr/>
-          <a:lstStyle/>
-          <a:p>
             <a:fld id="{334F72C3-CDF3-44A8-B602-1649B1728485}" type="datetime3">
               <a:rPr lang="en-US" smtClean="0"/>
-              <a:t>5 May 2026</a:t>
+              <a:t>7 July 2026</a:t>
             </a:fld>
             <a:endParaRPr lang="en-US"/>
           </a:p>
@@ -22487,6 +22256,80 @@
               <a:t>5</a:t>
             </a:fld>
             <a:endParaRPr lang="en-US"/>
+          </a:p>
+        </p:txBody>
+      </p:sp>
+      <p:sp>
+        <p:nvSpPr>
+          <p:cNvPr id="8" name="TextBox 7">
+            <a:extLst>
+              <a:ext uri="{FF2B5EF4-FFF2-40B4-BE49-F238E27FC236}">
+                <a16:creationId xmlns:a16="http://schemas.microsoft.com/office/drawing/2014/main" id="{641E1466-E833-8E48-6AEA-12069300FCB9}"/>
+              </a:ext>
+            </a:extLst>
+          </p:cNvPr>
+          <p:cNvSpPr txBox="1"/>
+          <p:nvPr/>
+        </p:nvSpPr>
+        <p:spPr>
+          <a:xfrm>
+            <a:off x="547688" y="1325881"/>
+            <a:ext cx="8593879" cy="2585323"/>
+          </a:xfrm>
+          <a:prstGeom prst="rect">
+            <a:avLst/>
+          </a:prstGeom>
+          <a:noFill/>
+        </p:spPr>
+        <p:txBody>
+          <a:bodyPr wrap="square">
+            <a:spAutoFit/>
+          </a:bodyPr>
+          <a:lstStyle/>
+          <a:p>
+            <a:r>
+              <a:rPr lang="en-US" dirty="0"/>
+              <a:t>Fall semester covers foundational technical skills:</a:t>
+            </a:r>
+          </a:p>
+          <a:p>
+            <a:endParaRPr lang="en-US" dirty="0"/>
+          </a:p>
+          <a:p>
+            <a:r>
+              <a:rPr lang="en-US" dirty="0"/>
+              <a:t>1. Python Programming (Weeks 1-9)</a:t>
+            </a:r>
+          </a:p>
+          <a:p>
+            <a:pPr marL="342900" indent="-342900">
+              <a:buAutoNum type="arabicPeriod"/>
+            </a:pPr>
+            <a:endParaRPr lang="en-US" dirty="0"/>
+          </a:p>
+          <a:p>
+            <a:r>
+              <a:rPr lang="en-US" dirty="0"/>
+              <a:t>2. Cloud Architecture (Weeks 1-7)</a:t>
+            </a:r>
+          </a:p>
+          <a:p>
+            <a:endParaRPr lang="en-US" dirty="0"/>
+          </a:p>
+          <a:p>
+            <a:r>
+              <a:rPr lang="en-US" dirty="0"/>
+              <a:t>3. DevOps (Weeks 8-12)</a:t>
+            </a:r>
+          </a:p>
+          <a:p>
+            <a:endParaRPr lang="en-US" dirty="0"/>
+          </a:p>
+          <a:p>
+            <a:r>
+              <a:rPr lang="en-US" dirty="0"/>
+              <a:t>4. Data Engineering (Weeks 10-12)</a:t>
+            </a:r>
           </a:p>
         </p:txBody>
       </p:sp>
@@ -22550,18 +22393,18 @@
       </p:sp>
       <p:sp>
         <p:nvSpPr>
-          <p:cNvPr id="3" name="Content Placeholder 2">
-            <a:extLst>
-              <a:ext uri="{FF2B5EF4-FFF2-40B4-BE49-F238E27FC236}">
-                <a16:creationId xmlns:a16="http://schemas.microsoft.com/office/drawing/2014/main" id="{87F97331-9A2A-82D0-BA4C-11D6F2FEC6A7}"/>
-              </a:ext>
-            </a:extLst>
-          </p:cNvPr>
-          <p:cNvSpPr>
-            <a:spLocks noGrp="1"/>
-          </p:cNvSpPr>
-          <p:nvPr>
-            <p:ph sz="half" idx="1"/>
+          <p:cNvPr id="5" name="Date Placeholder 4">
+            <a:extLst>
+              <a:ext uri="{FF2B5EF4-FFF2-40B4-BE49-F238E27FC236}">
+                <a16:creationId xmlns:a16="http://schemas.microsoft.com/office/drawing/2014/main" id="{55D9D8F6-9AEE-1FA3-E9E6-B67D676E10E9}"/>
+              </a:ext>
+            </a:extLst>
+          </p:cNvPr>
+          <p:cNvSpPr>
+            <a:spLocks noGrp="1"/>
+          </p:cNvSpPr>
+          <p:nvPr>
+            <p:ph type="dt" sz="half" idx="10"/>
           </p:nvPr>
         </p:nvSpPr>
         <p:spPr/>
@@ -22569,59 +22412,9 @@
           <a:bodyPr/>
           <a:lstStyle/>
           <a:p>
-            <a:endParaRPr lang="en-US"/>
-          </a:p>
-        </p:txBody>
-      </p:sp>
-      <p:sp>
-        <p:nvSpPr>
-          <p:cNvPr id="4" name="Content Placeholder 3">
-            <a:extLst>
-              <a:ext uri="{FF2B5EF4-FFF2-40B4-BE49-F238E27FC236}">
-                <a16:creationId xmlns:a16="http://schemas.microsoft.com/office/drawing/2014/main" id="{C41F3FCA-9EDB-EAC1-11EB-BFD0A0C5C5B3}"/>
-              </a:ext>
-            </a:extLst>
-          </p:cNvPr>
-          <p:cNvSpPr>
-            <a:spLocks noGrp="1"/>
-          </p:cNvSpPr>
-          <p:nvPr>
-            <p:ph sz="half" idx="2"/>
-          </p:nvPr>
-        </p:nvSpPr>
-        <p:spPr/>
-        <p:txBody>
-          <a:bodyPr/>
-          <a:lstStyle/>
-          <a:p>
-            <a:endParaRPr lang="en-US"/>
-          </a:p>
-        </p:txBody>
-      </p:sp>
-      <p:sp>
-        <p:nvSpPr>
-          <p:cNvPr id="5" name="Date Placeholder 4">
-            <a:extLst>
-              <a:ext uri="{FF2B5EF4-FFF2-40B4-BE49-F238E27FC236}">
-                <a16:creationId xmlns:a16="http://schemas.microsoft.com/office/drawing/2014/main" id="{55D9D8F6-9AEE-1FA3-E9E6-B67D676E10E9}"/>
-              </a:ext>
-            </a:extLst>
-          </p:cNvPr>
-          <p:cNvSpPr>
-            <a:spLocks noGrp="1"/>
-          </p:cNvSpPr>
-          <p:nvPr>
-            <p:ph type="dt" sz="half" idx="10"/>
-          </p:nvPr>
-        </p:nvSpPr>
-        <p:spPr/>
-        <p:txBody>
-          <a:bodyPr/>
-          <a:lstStyle/>
-          <a:p>
             <a:fld id="{334F72C3-CDF3-44A8-B602-1649B1728485}" type="datetime3">
               <a:rPr lang="en-US" smtClean="0"/>
-              <a:t>5 May 2026</a:t>
+              <a:t>7 July 2026</a:t>
             </a:fld>
             <a:endParaRPr lang="en-US"/>
           </a:p>
@@ -22654,6 +22447,71 @@
               <a:t>6</a:t>
             </a:fld>
             <a:endParaRPr lang="en-US"/>
+          </a:p>
+        </p:txBody>
+      </p:sp>
+      <p:sp>
+        <p:nvSpPr>
+          <p:cNvPr id="8" name="TextBox 7">
+            <a:extLst>
+              <a:ext uri="{FF2B5EF4-FFF2-40B4-BE49-F238E27FC236}">
+                <a16:creationId xmlns:a16="http://schemas.microsoft.com/office/drawing/2014/main" id="{A17A4A35-2DE0-7325-70DA-2F1B9B0FDB74}"/>
+              </a:ext>
+            </a:extLst>
+          </p:cNvPr>
+          <p:cNvSpPr txBox="1"/>
+          <p:nvPr/>
+        </p:nvSpPr>
+        <p:spPr>
+          <a:xfrm>
+            <a:off x="547688" y="1325881"/>
+            <a:ext cx="8593879" cy="2031325"/>
+          </a:xfrm>
+          <a:prstGeom prst="rect">
+            <a:avLst/>
+          </a:prstGeom>
+          <a:noFill/>
+        </p:spPr>
+        <p:txBody>
+          <a:bodyPr wrap="square">
+            <a:spAutoFit/>
+          </a:bodyPr>
+          <a:lstStyle/>
+          <a:p>
+            <a:r>
+              <a:rPr lang="en-US" dirty="0"/>
+              <a:t>Spring semester covers foundational technical skills:</a:t>
+            </a:r>
+          </a:p>
+          <a:p>
+            <a:endParaRPr lang="en-US" dirty="0"/>
+          </a:p>
+          <a:p>
+            <a:r>
+              <a:rPr lang="en-US" dirty="0"/>
+              <a:t>1. Cloud Native Development (Weeks 1, 3, 5, 7, 9, 11, 12)</a:t>
+            </a:r>
+          </a:p>
+          <a:p>
+            <a:pPr marL="342900" indent="-342900">
+              <a:buAutoNum type="arabicPeriod"/>
+            </a:pPr>
+            <a:endParaRPr lang="en-US" dirty="0"/>
+          </a:p>
+          <a:p>
+            <a:r>
+              <a:rPr lang="en-US" dirty="0"/>
+              <a:t>2. AI Practitioner (Weeks 2, 4, 6, 8, 10)</a:t>
+            </a:r>
+          </a:p>
+          <a:p>
+            <a:endParaRPr lang="en-US" dirty="0"/>
+          </a:p>
+          <a:p>
+            <a:r>
+              <a:rPr lang="en-US" dirty="0"/>
+              <a:t>3. Capstone Project (Throughout semester)</a:t>
+            </a:r>
           </a:p>
         </p:txBody>
       </p:sp>
@@ -22675,7 +22533,13 @@
   <p:cSld>
     <p:spTree>
       <p:nvGrpSpPr>
-        <p:cNvPr id="1" name=""/>
+        <p:cNvPr id="1" name="">
+          <a:extLst>
+            <a:ext uri="{FF2B5EF4-FFF2-40B4-BE49-F238E27FC236}">
+              <a16:creationId xmlns:a16="http://schemas.microsoft.com/office/drawing/2014/main" id="{3386BC3D-6F38-6673-F3AE-3B20832D35BF}"/>
+            </a:ext>
+          </a:extLst>
+        </p:cNvPr>
         <p:cNvGrpSpPr/>
         <p:nvPr/>
       </p:nvGrpSpPr>
@@ -22689,10 +22553,10 @@
       </p:grpSpPr>
       <p:sp>
         <p:nvSpPr>
-          <p:cNvPr id="2" name="Title 1">
-            <a:extLst>
-              <a:ext uri="{FF2B5EF4-FFF2-40B4-BE49-F238E27FC236}">
-                <a16:creationId xmlns:a16="http://schemas.microsoft.com/office/drawing/2014/main" id="{A5B4D2D9-F3DC-085B-D5E7-C14EEAC54563}"/>
+          <p:cNvPr id="6" name="Title 5">
+            <a:extLst>
+              <a:ext uri="{FF2B5EF4-FFF2-40B4-BE49-F238E27FC236}">
+                <a16:creationId xmlns:a16="http://schemas.microsoft.com/office/drawing/2014/main" id="{BB47E618-1C14-985F-8A61-F1CEE926ADA4}"/>
               </a:ext>
             </a:extLst>
           </p:cNvPr>
@@ -22709,54 +22573,18 @@
           <a:lstStyle/>
           <a:p>
             <a:r>
-              <a:rPr lang="en-US"/>
-              <a:t>Factory </a:t>
-            </a:r>
-            <a:r>
               <a:rPr lang="en-US" dirty="0"/>
-              <a:t>Specifics - TBD</a:t>
-            </a:r>
-          </a:p>
-        </p:txBody>
-      </p:sp>
-      <p:pic>
-        <p:nvPicPr>
-          <p:cNvPr id="9" name="Content Placeholder 8">
-            <a:extLst>
-              <a:ext uri="{FF2B5EF4-FFF2-40B4-BE49-F238E27FC236}">
-                <a16:creationId xmlns:a16="http://schemas.microsoft.com/office/drawing/2014/main" id="{43509F69-3232-70FE-5C54-E8FC23479089}"/>
-              </a:ext>
-            </a:extLst>
-          </p:cNvPr>
-          <p:cNvPicPr>
-            <a:picLocks noGrp="1" noChangeAspect="1"/>
-          </p:cNvPicPr>
-          <p:nvPr>
-            <p:ph idx="1"/>
-          </p:nvPr>
-        </p:nvPicPr>
-        <p:blipFill>
-          <a:blip r:embed="rId2"/>
-          <a:stretch>
-            <a:fillRect/>
-          </a:stretch>
-        </p:blipFill>
-        <p:spPr>
-          <a:xfrm>
-            <a:off x="1761397" y="1314155"/>
-            <a:ext cx="8231292" cy="4709656"/>
-          </a:xfrm>
-          <a:prstGeom prst="rect">
-            <a:avLst/>
-          </a:prstGeom>
-        </p:spPr>
-      </p:pic>
-      <p:sp>
-        <p:nvSpPr>
-          <p:cNvPr id="5" name="Date Placeholder 4">
-            <a:extLst>
-              <a:ext uri="{FF2B5EF4-FFF2-40B4-BE49-F238E27FC236}">
-                <a16:creationId xmlns:a16="http://schemas.microsoft.com/office/drawing/2014/main" id="{9EA9356A-C6A1-1CA4-96F8-C108165DDC0E}"/>
+              <a:t>CMU WEEKLY Schedule</a:t>
+            </a:r>
+          </a:p>
+        </p:txBody>
+      </p:sp>
+      <p:sp>
+        <p:nvSpPr>
+          <p:cNvPr id="4" name="Date Placeholder 3">
+            <a:extLst>
+              <a:ext uri="{FF2B5EF4-FFF2-40B4-BE49-F238E27FC236}">
+                <a16:creationId xmlns:a16="http://schemas.microsoft.com/office/drawing/2014/main" id="{37E6124D-3891-D59E-C41B-F56E11149F68}"/>
               </a:ext>
             </a:extLst>
           </p:cNvPr>
@@ -22772,9 +22600,9 @@
           <a:bodyPr/>
           <a:lstStyle/>
           <a:p>
-            <a:fld id="{334F72C3-CDF3-44A8-B602-1649B1728485}" type="datetime3">
+            <a:fld id="{AD622D1A-DF83-41A8-85FF-04D90BF831D3}" type="datetime3">
               <a:rPr lang="en-US" smtClean="0"/>
-              <a:t>5 May 2026</a:t>
+              <a:t>7 July 2026</a:t>
             </a:fld>
             <a:endParaRPr lang="en-US"/>
           </a:p>
@@ -22782,10 +22610,10 @@
       </p:sp>
       <p:sp>
         <p:nvSpPr>
-          <p:cNvPr id="6" name="Slide Number Placeholder 5">
-            <a:extLst>
-              <a:ext uri="{FF2B5EF4-FFF2-40B4-BE49-F238E27FC236}">
-                <a16:creationId xmlns:a16="http://schemas.microsoft.com/office/drawing/2014/main" id="{ABF44555-9573-5A24-777B-0CE5D875AE62}"/>
+          <p:cNvPr id="5" name="Slide Number Placeholder 4">
+            <a:extLst>
+              <a:ext uri="{FF2B5EF4-FFF2-40B4-BE49-F238E27FC236}">
+                <a16:creationId xmlns:a16="http://schemas.microsoft.com/office/drawing/2014/main" id="{12E8E160-42F6-F29C-EA29-ED38502BDE1A}"/>
               </a:ext>
             </a:extLst>
           </p:cNvPr>
@@ -22810,10 +22638,154 @@
           </a:p>
         </p:txBody>
       </p:sp>
+      <p:sp>
+        <p:nvSpPr>
+          <p:cNvPr id="3" name="TextBox 2">
+            <a:extLst>
+              <a:ext uri="{FF2B5EF4-FFF2-40B4-BE49-F238E27FC236}">
+                <a16:creationId xmlns:a16="http://schemas.microsoft.com/office/drawing/2014/main" id="{02E7E051-1799-8452-2F3B-55CAF6A69ADE}"/>
+              </a:ext>
+            </a:extLst>
+          </p:cNvPr>
+          <p:cNvSpPr txBox="1"/>
+          <p:nvPr/>
+        </p:nvSpPr>
+        <p:spPr>
+          <a:xfrm>
+            <a:off x="389108" y="1056411"/>
+            <a:ext cx="12782144" cy="5355312"/>
+          </a:xfrm>
+          <a:prstGeom prst="rect">
+            <a:avLst/>
+          </a:prstGeom>
+          <a:noFill/>
+        </p:spPr>
+        <p:txBody>
+          <a:bodyPr wrap="square">
+            <a:spAutoFit/>
+          </a:bodyPr>
+          <a:lstStyle/>
+          <a:p>
+            <a:r>
+              <a:rPr lang="en-US" dirty="0"/>
+              <a:t>Monday:</a:t>
+            </a:r>
+          </a:p>
+          <a:p>
+            <a:r>
+              <a:rPr lang="en-US" dirty="0">
+                <a:highlight>
+                  <a:srgbClr val="00FF00"/>
+                </a:highlight>
+              </a:rPr>
+              <a:t>• 9:30-11:30 AM: Two lectures</a:t>
+            </a:r>
+          </a:p>
+          <a:p>
+            <a:r>
+              <a:rPr lang="en-US" dirty="0">
+                <a:highlight>
+                  <a:srgbClr val="00FF00"/>
+                </a:highlight>
+              </a:rPr>
+              <a:t>• 11:30 AM-12:20 PM: Review session with Teaching Assistants</a:t>
+            </a:r>
+          </a:p>
+          <a:p>
+            <a:endParaRPr lang="en-US" dirty="0"/>
+          </a:p>
+          <a:p>
+            <a:r>
+              <a:rPr lang="en-US" dirty="0"/>
+              <a:t>Tuesday:</a:t>
+            </a:r>
+          </a:p>
+          <a:p>
+            <a:r>
+              <a:rPr lang="en-US" dirty="0"/>
+              <a:t>• No scheduled class activities, time for project work and self-study</a:t>
+            </a:r>
+          </a:p>
+          <a:p>
+            <a:endParaRPr lang="en-US" dirty="0"/>
+          </a:p>
+          <a:p>
+            <a:r>
+              <a:rPr lang="en-US" dirty="0"/>
+              <a:t>Wednesday:</a:t>
+            </a:r>
+          </a:p>
+          <a:p>
+            <a:r>
+              <a:rPr lang="en-US" dirty="0">
+                <a:highlight>
+                  <a:srgbClr val="00FF00"/>
+                </a:highlight>
+              </a:rPr>
+              <a:t>• 9:30 AM-12:00 PM: Recitations for Group A</a:t>
+            </a:r>
+          </a:p>
+          <a:p>
+            <a:r>
+              <a:rPr lang="en-US" dirty="0">
+                <a:highlight>
+                  <a:srgbClr val="00FF00"/>
+                </a:highlight>
+              </a:rPr>
+              <a:t>• 1:00-3:30 PM: Recitations for Group B</a:t>
+            </a:r>
+          </a:p>
+          <a:p>
+            <a:endParaRPr lang="en-US" dirty="0"/>
+          </a:p>
+          <a:p>
+            <a:r>
+              <a:rPr lang="en-US" dirty="0"/>
+              <a:t>Thursday:</a:t>
+            </a:r>
+          </a:p>
+          <a:p>
+            <a:r>
+              <a:rPr lang="en-US" dirty="0"/>
+              <a:t>• Weekly quiz opens (1 hour to complete, due by midnight) , time for project work and self-study</a:t>
+            </a:r>
+          </a:p>
+          <a:p>
+            <a:endParaRPr lang="en-US" dirty="0"/>
+          </a:p>
+          <a:p>
+            <a:r>
+              <a:rPr lang="en-US" dirty="0"/>
+              <a:t>Friday:</a:t>
+            </a:r>
+          </a:p>
+          <a:p>
+            <a:r>
+              <a:rPr lang="en-US" dirty="0"/>
+              <a:t>• Next week content and primer modules open</a:t>
+            </a:r>
+          </a:p>
+          <a:p>
+            <a:endParaRPr lang="en-US" dirty="0"/>
+          </a:p>
+          <a:p>
+            <a:r>
+              <a:rPr lang="en-US" dirty="0"/>
+              <a:t>Saturday:</a:t>
+            </a:r>
+          </a:p>
+          <a:p>
+            <a:r>
+              <a:rPr lang="en-US" dirty="0"/>
+              <a:t>• Weekly projects due; Previous week’s discussion responses due</a:t>
+            </a:r>
+          </a:p>
+        </p:txBody>
+      </p:sp>
     </p:spTree>
     <p:extLst>
       <p:ext uri="{BB962C8B-B14F-4D97-AF65-F5344CB8AC3E}">
-        <p14:creationId xmlns:p14="http://schemas.microsoft.com/office/powerpoint/2010/main" val="121590568"/>
+        <p14:creationId xmlns:p14="http://schemas.microsoft.com/office/powerpoint/2010/main" val="3704109703"/>
       </p:ext>
     </p:extLst>
   </p:cSld>
@@ -22842,10 +22814,10 @@
       </p:grpSpPr>
       <p:sp>
         <p:nvSpPr>
-          <p:cNvPr id="6" name="Title 5">
-            <a:extLst>
-              <a:ext uri="{FF2B5EF4-FFF2-40B4-BE49-F238E27FC236}">
-                <a16:creationId xmlns:a16="http://schemas.microsoft.com/office/drawing/2014/main" id="{69E56E2B-F7F0-66BD-FE9C-392C14379B8C}"/>
+          <p:cNvPr id="2" name="Title 1">
+            <a:extLst>
+              <a:ext uri="{FF2B5EF4-FFF2-40B4-BE49-F238E27FC236}">
+                <a16:creationId xmlns:a16="http://schemas.microsoft.com/office/drawing/2014/main" id="{F16CF2C6-D220-675D-1DA2-0D02F5793D17}"/>
               </a:ext>
             </a:extLst>
           </p:cNvPr>
@@ -22863,17 +22835,17 @@
           <a:p>
             <a:r>
               <a:rPr lang="en-US" dirty="0"/>
-              <a:t>Daily Schedule</a:t>
-            </a:r>
-          </a:p>
-        </p:txBody>
-      </p:sp>
-      <p:sp>
-        <p:nvSpPr>
-          <p:cNvPr id="7" name="Content Placeholder 6">
-            <a:extLst>
-              <a:ext uri="{FF2B5EF4-FFF2-40B4-BE49-F238E27FC236}">
-                <a16:creationId xmlns:a16="http://schemas.microsoft.com/office/drawing/2014/main" id="{27ED88B9-3357-EC07-CBC8-2BC307869C64}"/>
+              <a:t>Instructor Intros</a:t>
+            </a:r>
+          </a:p>
+        </p:txBody>
+      </p:sp>
+      <p:sp>
+        <p:nvSpPr>
+          <p:cNvPr id="3" name="Content Placeholder 2">
+            <a:extLst>
+              <a:ext uri="{FF2B5EF4-FFF2-40B4-BE49-F238E27FC236}">
+                <a16:creationId xmlns:a16="http://schemas.microsoft.com/office/drawing/2014/main" id="{2C7056F4-5930-A8DB-D462-2F188819AE92}"/>
               </a:ext>
             </a:extLst>
           </p:cNvPr>
@@ -22891,26 +22863,52 @@
           <a:p>
             <a:r>
               <a:rPr lang="en-US" dirty="0"/>
-              <a:t>0900 – UTC – Morning class</a:t>
-            </a:r>
-          </a:p>
-          <a:p>
+              <a:t>MAJ Ryan Neville</a:t>
+            </a:r>
+          </a:p>
+          <a:p>
+            <a:pPr lvl="1"/>
             <a:r>
               <a:rPr lang="en-US" dirty="0"/>
-              <a:t>1300 – UTC – Afternoon class</a:t>
-            </a:r>
-          </a:p>
-          <a:p>
-            <a:endParaRPr lang="en-US" dirty="0"/>
-          </a:p>
-        </p:txBody>
-      </p:sp>
-      <p:sp>
-        <p:nvSpPr>
-          <p:cNvPr id="8" name="Content Placeholder 7">
-            <a:extLst>
-              <a:ext uri="{FF2B5EF4-FFF2-40B4-BE49-F238E27FC236}">
-                <a16:creationId xmlns:a16="http://schemas.microsoft.com/office/drawing/2014/main" id="{24E78C1C-E064-347C-2437-40225FA9E3E6}"/>
+              <a:t>Commissioned in 2012, Engineer</a:t>
+            </a:r>
+          </a:p>
+          <a:p>
+            <a:pPr lvl="1"/>
+            <a:r>
+              <a:rPr lang="en-US" dirty="0"/>
+              <a:t>Engineer Diver (2013 – 2020)</a:t>
+            </a:r>
+          </a:p>
+          <a:p>
+            <a:pPr lvl="1"/>
+            <a:r>
+              <a:rPr lang="en-US" dirty="0"/>
+              <a:t>Grad School (2020-2021)</a:t>
+            </a:r>
+          </a:p>
+          <a:p>
+            <a:pPr lvl="1"/>
+            <a:r>
+              <a:rPr lang="en-US" dirty="0"/>
+              <a:t>USMA Assistant Professor (2021-2025)</a:t>
+            </a:r>
+          </a:p>
+          <a:p>
+            <a:pPr lvl="1"/>
+            <a:r>
+              <a:rPr lang="en-US" dirty="0"/>
+              <a:t>AI2C Technician (2025 – now)</a:t>
+            </a:r>
+          </a:p>
+        </p:txBody>
+      </p:sp>
+      <p:sp>
+        <p:nvSpPr>
+          <p:cNvPr id="4" name="Content Placeholder 3">
+            <a:extLst>
+              <a:ext uri="{FF2B5EF4-FFF2-40B4-BE49-F238E27FC236}">
+                <a16:creationId xmlns:a16="http://schemas.microsoft.com/office/drawing/2014/main" id="{F5EAF692-C1F1-617F-9C2D-8BD3836DE6F0}"/>
               </a:ext>
             </a:extLst>
           </p:cNvPr>
@@ -22926,16 +22924,68 @@
           <a:bodyPr/>
           <a:lstStyle/>
           <a:p>
-            <a:endParaRPr lang="en-US"/>
-          </a:p>
-        </p:txBody>
-      </p:sp>
-      <p:sp>
-        <p:nvSpPr>
-          <p:cNvPr id="4" name="Date Placeholder 3">
-            <a:extLst>
-              <a:ext uri="{FF2B5EF4-FFF2-40B4-BE49-F238E27FC236}">
-                <a16:creationId xmlns:a16="http://schemas.microsoft.com/office/drawing/2014/main" id="{C9AE2388-31A1-DD2E-2E5F-A5BD9A217891}"/>
+            <a:r>
+              <a:rPr lang="en-US" dirty="0"/>
+              <a:t>MAJ Ethan Shafer</a:t>
+            </a:r>
+          </a:p>
+          <a:p>
+            <a:pPr lvl="1"/>
+            <a:r>
+              <a:rPr lang="en-US" dirty="0"/>
+              <a:t>Commissioned in 2013, Air Defense</a:t>
+            </a:r>
+          </a:p>
+          <a:p>
+            <a:pPr lvl="1"/>
+            <a:r>
+              <a:rPr lang="en-US" dirty="0"/>
+              <a:t>PL / XO</a:t>
+            </a:r>
+          </a:p>
+          <a:p>
+            <a:pPr lvl="1"/>
+            <a:r>
+              <a:rPr lang="en-US" dirty="0"/>
+              <a:t>VTIP 26B</a:t>
+            </a:r>
+          </a:p>
+          <a:p>
+            <a:pPr lvl="1"/>
+            <a:r>
+              <a:rPr lang="en-US" dirty="0"/>
+              <a:t>Automations OIC</a:t>
+            </a:r>
+          </a:p>
+          <a:p>
+            <a:pPr lvl="1"/>
+            <a:r>
+              <a:rPr lang="en-US" dirty="0"/>
+              <a:t>Grad School</a:t>
+            </a:r>
+          </a:p>
+          <a:p>
+            <a:pPr lvl="1"/>
+            <a:r>
+              <a:rPr lang="en-US" dirty="0"/>
+              <a:t>USMA Assistant Professor</a:t>
+            </a:r>
+          </a:p>
+          <a:p>
+            <a:pPr lvl="1"/>
+            <a:r>
+              <a:rPr lang="en-US" dirty="0"/>
+              <a:t>AI2C Technician, R&amp;E</a:t>
+            </a:r>
+          </a:p>
+        </p:txBody>
+      </p:sp>
+      <p:sp>
+        <p:nvSpPr>
+          <p:cNvPr id="5" name="Date Placeholder 4">
+            <a:extLst>
+              <a:ext uri="{FF2B5EF4-FFF2-40B4-BE49-F238E27FC236}">
+                <a16:creationId xmlns:a16="http://schemas.microsoft.com/office/drawing/2014/main" id="{4CF0ACD7-0217-6059-FF43-8F111E44CC0B}"/>
               </a:ext>
             </a:extLst>
           </p:cNvPr>
@@ -22951,9 +23001,9 @@
           <a:bodyPr/>
           <a:lstStyle/>
           <a:p>
-            <a:fld id="{AD622D1A-DF83-41A8-85FF-04D90BF831D3}" type="datetime3">
+            <a:fld id="{334F72C3-CDF3-44A8-B602-1649B1728485}" type="datetime3">
               <a:rPr lang="en-US" smtClean="0"/>
-              <a:t>5 May 2026</a:t>
+              <a:t>7 July 2026</a:t>
             </a:fld>
             <a:endParaRPr lang="en-US"/>
           </a:p>
@@ -22961,10 +23011,10 @@
       </p:sp>
       <p:sp>
         <p:nvSpPr>
-          <p:cNvPr id="5" name="Slide Number Placeholder 4">
-            <a:extLst>
-              <a:ext uri="{FF2B5EF4-FFF2-40B4-BE49-F238E27FC236}">
-                <a16:creationId xmlns:a16="http://schemas.microsoft.com/office/drawing/2014/main" id="{94E1A057-81B7-19AA-B0FD-7BF9FCA712CF}"/>
+          <p:cNvPr id="6" name="Slide Number Placeholder 5">
+            <a:extLst>
+              <a:ext uri="{FF2B5EF4-FFF2-40B4-BE49-F238E27FC236}">
+                <a16:creationId xmlns:a16="http://schemas.microsoft.com/office/drawing/2014/main" id="{78679715-71BB-9FB0-36B5-F206A17975F3}"/>
               </a:ext>
             </a:extLst>
           </p:cNvPr>
@@ -22992,7 +23042,7 @@
     </p:spTree>
     <p:extLst>
       <p:ext uri="{BB962C8B-B14F-4D97-AF65-F5344CB8AC3E}">
-        <p14:creationId xmlns:p14="http://schemas.microsoft.com/office/powerpoint/2010/main" val="1685140285"/>
+        <p14:creationId xmlns:p14="http://schemas.microsoft.com/office/powerpoint/2010/main" val="65544215"/>
       </p:ext>
     </p:extLst>
   </p:cSld>
@@ -23024,7 +23074,7 @@
           <p:cNvPr id="2" name="Title 1">
             <a:extLst>
               <a:ext uri="{FF2B5EF4-FFF2-40B4-BE49-F238E27FC236}">
-                <a16:creationId xmlns:a16="http://schemas.microsoft.com/office/drawing/2014/main" id="{F16CF2C6-D220-675D-1DA2-0D02F5793D17}"/>
+                <a16:creationId xmlns:a16="http://schemas.microsoft.com/office/drawing/2014/main" id="{A7407C8E-BBE1-1620-CD8C-FDEE7F1AEB9F}"/>
               </a:ext>
             </a:extLst>
           </p:cNvPr>
@@ -23042,7 +23092,7 @@
           <a:p>
             <a:r>
               <a:rPr lang="en-US" dirty="0"/>
-              <a:t>Instructor Intros</a:t>
+              <a:t>Class Intros</a:t>
             </a:r>
           </a:p>
         </p:txBody>
@@ -23052,7 +23102,7 @@
           <p:cNvPr id="3" name="Content Placeholder 2">
             <a:extLst>
               <a:ext uri="{FF2B5EF4-FFF2-40B4-BE49-F238E27FC236}">
-                <a16:creationId xmlns:a16="http://schemas.microsoft.com/office/drawing/2014/main" id="{2C7056F4-5930-A8DB-D462-2F188819AE92}"/>
+                <a16:creationId xmlns:a16="http://schemas.microsoft.com/office/drawing/2014/main" id="{5899F202-B34B-3F90-05A2-14991C467CF4}"/>
               </a:ext>
             </a:extLst>
           </p:cNvPr>
@@ -23068,24 +23118,94 @@
           <a:bodyPr/>
           <a:lstStyle/>
           <a:p>
-            <a:endParaRPr lang="en-US"/>
-          </a:p>
-        </p:txBody>
-      </p:sp>
-      <p:sp>
-        <p:nvSpPr>
-          <p:cNvPr id="4" name="Content Placeholder 3">
-            <a:extLst>
-              <a:ext uri="{FF2B5EF4-FFF2-40B4-BE49-F238E27FC236}">
-                <a16:creationId xmlns:a16="http://schemas.microsoft.com/office/drawing/2014/main" id="{F5EAF692-C1F1-617F-9C2D-8BD3836DE6F0}"/>
-              </a:ext>
-            </a:extLst>
-          </p:cNvPr>
-          <p:cNvSpPr>
-            <a:spLocks noGrp="1"/>
-          </p:cNvSpPr>
-          <p:nvPr>
-            <p:ph sz="half" idx="2"/>
+            <a:pPr lvl="0"/>
+            <a:r>
+              <a:rPr lang="en-US" dirty="0">
+                <a:sym typeface="Arial"/>
+              </a:rPr>
+              <a:t> Name</a:t>
+            </a:r>
+          </a:p>
+          <a:p>
+            <a:pPr lvl="0"/>
+            <a:endParaRPr lang="en-US" dirty="0">
+              <a:sym typeface="Arial"/>
+            </a:endParaRPr>
+          </a:p>
+          <a:p>
+            <a:pPr lvl="0"/>
+            <a:r>
+              <a:rPr lang="en-US" dirty="0">
+                <a:sym typeface="Arial"/>
+              </a:rPr>
+              <a:t> Rank</a:t>
+            </a:r>
+            <a:endParaRPr lang="en-US" dirty="0"/>
+          </a:p>
+          <a:p>
+            <a:pPr lvl="0"/>
+            <a:endParaRPr lang="en-US" dirty="0">
+              <a:sym typeface="Arial"/>
+            </a:endParaRPr>
+          </a:p>
+          <a:p>
+            <a:pPr lvl="0"/>
+            <a:r>
+              <a:rPr lang="en-US" dirty="0">
+                <a:sym typeface="Arial"/>
+              </a:rPr>
+              <a:t> What you do in the Army</a:t>
+            </a:r>
+            <a:endParaRPr lang="en-US" dirty="0"/>
+          </a:p>
+          <a:p>
+            <a:pPr lvl="0"/>
+            <a:endParaRPr lang="en-US" dirty="0">
+              <a:sym typeface="Arial"/>
+            </a:endParaRPr>
+          </a:p>
+          <a:p>
+            <a:pPr lvl="0"/>
+            <a:r>
+              <a:rPr lang="en-US" dirty="0">
+                <a:sym typeface="Arial"/>
+              </a:rPr>
+              <a:t> Where you're coming from</a:t>
+            </a:r>
+            <a:endParaRPr lang="en-US" dirty="0"/>
+          </a:p>
+          <a:p>
+            <a:pPr lvl="0"/>
+            <a:endParaRPr lang="en-US" dirty="0">
+              <a:sym typeface="Arial"/>
+            </a:endParaRPr>
+          </a:p>
+          <a:p>
+            <a:pPr lvl="0"/>
+            <a:r>
+              <a:rPr lang="en-US" dirty="0">
+                <a:sym typeface="Arial"/>
+              </a:rPr>
+              <a:t> Your experience level with AI/Tech/Coding</a:t>
+            </a:r>
+            <a:endParaRPr lang="en-US" dirty="0"/>
+          </a:p>
+        </p:txBody>
+      </p:sp>
+      <p:sp>
+        <p:nvSpPr>
+          <p:cNvPr id="5" name="Date Placeholder 4">
+            <a:extLst>
+              <a:ext uri="{FF2B5EF4-FFF2-40B4-BE49-F238E27FC236}">
+                <a16:creationId xmlns:a16="http://schemas.microsoft.com/office/drawing/2014/main" id="{3D640EFC-913A-CB78-1FFB-140336903F5C}"/>
+              </a:ext>
+            </a:extLst>
+          </p:cNvPr>
+          <p:cNvSpPr>
+            <a:spLocks noGrp="1"/>
+          </p:cNvSpPr>
+          <p:nvPr>
+            <p:ph type="dt" sz="half" idx="10"/>
           </p:nvPr>
         </p:nvSpPr>
         <p:spPr/>
@@ -23093,34 +23213,9 @@
           <a:bodyPr/>
           <a:lstStyle/>
           <a:p>
-            <a:endParaRPr lang="en-US"/>
-          </a:p>
-        </p:txBody>
-      </p:sp>
-      <p:sp>
-        <p:nvSpPr>
-          <p:cNvPr id="5" name="Date Placeholder 4">
-            <a:extLst>
-              <a:ext uri="{FF2B5EF4-FFF2-40B4-BE49-F238E27FC236}">
-                <a16:creationId xmlns:a16="http://schemas.microsoft.com/office/drawing/2014/main" id="{4CF0ACD7-0217-6059-FF43-8F111E44CC0B}"/>
-              </a:ext>
-            </a:extLst>
-          </p:cNvPr>
-          <p:cNvSpPr>
-            <a:spLocks noGrp="1"/>
-          </p:cNvSpPr>
-          <p:nvPr>
-            <p:ph type="dt" sz="half" idx="10"/>
-          </p:nvPr>
-        </p:nvSpPr>
-        <p:spPr/>
-        <p:txBody>
-          <a:bodyPr/>
-          <a:lstStyle/>
-          <a:p>
             <a:fld id="{334F72C3-CDF3-44A8-B602-1649B1728485}" type="datetime3">
               <a:rPr lang="en-US" smtClean="0"/>
-              <a:t>5 May 2026</a:t>
+              <a:t>7 July 2026</a:t>
             </a:fld>
             <a:endParaRPr lang="en-US"/>
           </a:p>
@@ -23131,7 +23226,7 @@
           <p:cNvPr id="6" name="Slide Number Placeholder 5">
             <a:extLst>
               <a:ext uri="{FF2B5EF4-FFF2-40B4-BE49-F238E27FC236}">
-                <a16:creationId xmlns:a16="http://schemas.microsoft.com/office/drawing/2014/main" id="{78679715-71BB-9FB0-36B5-F206A17975F3}"/>
+                <a16:creationId xmlns:a16="http://schemas.microsoft.com/office/drawing/2014/main" id="{EB76AA8E-E414-56E9-5916-7185B58E62D2}"/>
               </a:ext>
             </a:extLst>
           </p:cNvPr>
@@ -23159,7 +23254,7 @@
     </p:spTree>
     <p:extLst>
       <p:ext uri="{BB962C8B-B14F-4D97-AF65-F5344CB8AC3E}">
-        <p14:creationId xmlns:p14="http://schemas.microsoft.com/office/powerpoint/2010/main" val="65544215"/>
+        <p14:creationId xmlns:p14="http://schemas.microsoft.com/office/powerpoint/2010/main" val="1247108587"/>
       </p:ext>
     </p:extLst>
   </p:cSld>
@@ -23725,187 +23820,6 @@
 </file>
 
 <file path=customXml/item1.xml><?xml version="1.0" encoding="utf-8"?>
-<p:properties xmlns:p="http://schemas.microsoft.com/office/2006/metadata/properties" xmlns:xsi="http://www.w3.org/2001/XMLSchema-instance" xmlns:pc="http://schemas.microsoft.com/office/infopath/2007/PartnerControls">
-  <documentManagement>
-    <Name_x0028_Outlook_x0029_ xmlns="819a213c-e595-4af7-868c-5311d0f07b09">
-      <UserInfo>
-        <DisplayName/>
-        <AccountId xsi:nil="true"/>
-        <AccountType/>
-      </UserInfo>
-    </Name_x0028_Outlook_x0029_>
-    <_ip_UnifiedCompliancePolicyUIAction xmlns="http://schemas.microsoft.com/sharepoint/v3" xsi:nil="true"/>
-    <TaxCatchAll xmlns="43c4306d-bcae-48a3-b5b4-6245fba36c72">
-      <Value>117</Value>
-      <Value>336</Value>
-      <Value>352</Value>
-      <Value>332</Value>
-      <Value>330</Value>
-      <Value>5</Value>
-      <Value>88</Value>
-      <Value>2</Value>
-      <Value>1</Value>
-    </TaxCatchAll>
-    <Project xmlns="819a213c-e595-4af7-868c-5311d0f07b09">Shrike</Project>
-    <b3e0283348f04d719dc2db6c1ad0eab0 xmlns="819a213c-e595-4af7-868c-5311d0f07b09">
-      <Terms xmlns="http://schemas.microsoft.com/office/infopath/2007/PartnerControls"/>
-    </b3e0283348f04d719dc2db6c1ad0eab0>
-    <kf4578e6b9744d06891b013fb9171991 xmlns="819a213c-e595-4af7-868c-5311d0f07b09">
-      <Terms xmlns="http://schemas.microsoft.com/office/infopath/2007/PartnerControls">
-        <TermInfo xmlns="http://schemas.microsoft.com/office/infopath/2007/PartnerControls">
-          <TermName xmlns="http://schemas.microsoft.com/office/infopath/2007/PartnerControls">FCAI</TermName>
-          <TermId xmlns="http://schemas.microsoft.com/office/infopath/2007/PartnerControls">fd9e9f27-4afa-4bd6-9815-b72522a6dee4</TermId>
-        </TermInfo>
-      </Terms>
-    </kf4578e6b9744d06891b013fb9171991>
-    <e7bf107ab2e246c2ae3b25ccb19c4fe7 xmlns="819a213c-e595-4af7-868c-5311d0f07b09">
-      <Terms xmlns="http://schemas.microsoft.com/office/infopath/2007/PartnerControls"/>
-    </e7bf107ab2e246c2ae3b25ccb19c4fe7>
-    <Status xmlns="819a213c-e595-4af7-868c-5311d0f07b09">NA</Status>
-    <k1cd0d7a50e348e5b2cecacdbb53a3ff xmlns="819a213c-e595-4af7-868c-5311d0f07b09">
-      <Terms xmlns="http://schemas.microsoft.com/office/infopath/2007/PartnerControls">
-        <TermInfo xmlns="http://schemas.microsoft.com/office/infopath/2007/PartnerControls">
-          <TermName xmlns="http://schemas.microsoft.com/office/infopath/2007/PartnerControls">NA</TermName>
-          <TermId xmlns="http://schemas.microsoft.com/office/infopath/2007/PartnerControls">6c779868-fdfe-4433-a583-74f72965e832</TermId>
-        </TermInfo>
-      </Terms>
-    </k1cd0d7a50e348e5b2cecacdbb53a3ff>
-    <k4bd3d618c344bb496a0035fa1bfa95e xmlns="819a213c-e595-4af7-868c-5311d0f07b09">
-      <Terms xmlns="http://schemas.microsoft.com/office/infopath/2007/PartnerControls">
-        <TermInfo xmlns="http://schemas.microsoft.com/office/infopath/2007/PartnerControls">
-          <TermName xmlns="http://schemas.microsoft.com/office/infopath/2007/PartnerControls">NA</TermName>
-          <TermId xmlns="http://schemas.microsoft.com/office/infopath/2007/PartnerControls">14e9068e-14f9-49cc-a753-38a742264b27</TermId>
-        </TermInfo>
-      </Terms>
-    </k4bd3d618c344bb496a0035fa1bfa95e>
-    <m3911d227d12438196938f21bccbb829 xmlns="819a213c-e595-4af7-868c-5311d0f07b09">
-      <Terms xmlns="http://schemas.microsoft.com/office/infopath/2007/PartnerControls">
-        <TermInfo xmlns="http://schemas.microsoft.com/office/infopath/2007/PartnerControls">
-          <TermName xmlns="http://schemas.microsoft.com/office/infopath/2007/PartnerControls">Unclassified</TermName>
-          <TermId xmlns="http://schemas.microsoft.com/office/infopath/2007/PartnerControls">0e44ab2e-9e75-4d69-bacf-b9adbba64961</TermId>
-        </TermInfo>
-      </Terms>
-    </m3911d227d12438196938f21bccbb829>
-    <j85403ed819e4ad59bb8aa44734c7278 xmlns="819a213c-e595-4af7-868c-5311d0f07b09">
-      <Terms xmlns="http://schemas.microsoft.com/office/infopath/2007/PartnerControls">
-        <TermInfo xmlns="http://schemas.microsoft.com/office/infopath/2007/PartnerControls">
-          <TermName xmlns="http://schemas.microsoft.com/office/infopath/2007/PartnerControls">NA</TermName>
-          <TermId xmlns="http://schemas.microsoft.com/office/infopath/2007/PartnerControls">c413e2e5-7da6-4fb4-9318-c07a4c95104c</TermId>
-        </TermInfo>
-      </Terms>
-    </j85403ed819e4ad59bb8aa44734c7278>
-    <e41571422c3345b4bda9d3ac979b0442 xmlns="819a213c-e595-4af7-868c-5311d0f07b09">
-      <Terms xmlns="http://schemas.microsoft.com/office/infopath/2007/PartnerControls">
-        <TermInfo xmlns="http://schemas.microsoft.com/office/infopath/2007/PartnerControls">
-          <TermName xmlns="http://schemas.microsoft.com/office/infopath/2007/PartnerControls">Destroy</TermName>
-          <TermId xmlns="http://schemas.microsoft.com/office/infopath/2007/PartnerControls">81460359-14dd-47b4-9102-5fada66d1614</TermId>
-        </TermInfo>
-      </Terms>
-    </e41571422c3345b4bda9d3ac979b0442>
-    <b2c7cbb6fa064dd095a8ebf73878e15c xmlns="819a213c-e595-4af7-868c-5311d0f07b09">
-      <Terms xmlns="http://schemas.microsoft.com/office/infopath/2007/PartnerControls">
-        <TermInfo xmlns="http://schemas.microsoft.com/office/infopath/2007/PartnerControls">
-          <TermName xmlns="http://schemas.microsoft.com/office/infopath/2007/PartnerControls">D</TermName>
-          <TermId xmlns="http://schemas.microsoft.com/office/infopath/2007/PartnerControls">e66b2925-d207-445d-a7ac-7bf5587a61c3</TermId>
-        </TermInfo>
-      </Terms>
-    </b2c7cbb6fa064dd095a8ebf73878e15c>
-    <n050dff107b041e7a8136cabb03c9f16 xmlns="819a213c-e595-4af7-868c-5311d0f07b09">
-      <Terms xmlns="http://schemas.microsoft.com/office/infopath/2007/PartnerControls"/>
-    </n050dff107b041e7a8136cabb03c9f16>
-    <dbcc5996da9743a2aff52ccb96daf316 xmlns="819a213c-e595-4af7-868c-5311d0f07b09">
-      <Terms xmlns="http://schemas.microsoft.com/office/infopath/2007/PartnerControls"/>
-    </dbcc5996da9743a2aff52ccb96daf316>
-    <_ip_UnifiedCompliancePolicyProperties xmlns="http://schemas.microsoft.com/sharepoint/v3" xsi:nil="true"/>
-    <Comments xmlns="819a213c-e595-4af7-868c-5311d0f07b09" xsi:nil="true"/>
-    <_dlc_DocIdPersistId xmlns="43c4306d-bcae-48a3-b5b4-6245fba36c72" xsi:nil="true"/>
-    <_dlc_DocIdUrl xmlns="43c4306d-bcae-48a3-b5b4-6245fba36c72">
-      <Url>https://armyeitaas.sharepoint-mil.us/teams/AI2CKMDevelopmentTeam/_layouts/15/DocIdRedir.aspx?ID=PNCAVZZWCJMJ-719779062-26496</Url>
-      <Description>PNCAVZZWCJMJ-719779062-26496</Description>
-    </_dlc_DocIdUrl>
-    <Teams xmlns="819a213c-e595-4af7-868c-5311d0f07b09">NA</Teams>
-    <lcf76f155ced4ddcb4097134ff3c332f xmlns="819a213c-e595-4af7-868c-5311d0f07b09">
-      <Terms xmlns="http://schemas.microsoft.com/office/infopath/2007/PartnerControls"/>
-    </lcf76f155ced4ddcb4097134ff3c332f>
-    <kf187aa08ef840c0be306c2b7cf181cc xmlns="819a213c-e595-4af7-868c-5311d0f07b09">
-      <Terms xmlns="http://schemas.microsoft.com/office/infopath/2007/PartnerControls"/>
-    </kf187aa08ef840c0be306c2b7cf181cc>
-    <k8ed72fc0ac74230bc2bce9a30aa3ff1 xmlns="819a213c-e595-4af7-868c-5311d0f07b09">
-      <Terms xmlns="http://schemas.microsoft.com/office/infopath/2007/PartnerControls"/>
-    </k8ed72fc0ac74230bc2bce9a30aa3ff1>
-    <j3cec2dc15da4ea9ae4c2914aab734b8 xmlns="819a213c-e595-4af7-868c-5311d0f07b09">
-      <Terms xmlns="http://schemas.microsoft.com/office/infopath/2007/PartnerControls">
-        <TermInfo xmlns="http://schemas.microsoft.com/office/infopath/2007/PartnerControls">
-          <TermName xmlns="http://schemas.microsoft.com/office/infopath/2007/PartnerControls">Unofficial</TermName>
-          <TermId xmlns="http://schemas.microsoft.com/office/infopath/2007/PartnerControls">fb72a3e1-cd07-4e90-8aa1-1e35bcf7448f</TermId>
-        </TermInfo>
-      </Terms>
-    </j3cec2dc15da4ea9ae4c2914aab734b8>
-    <_dlc_DocId xmlns="43c4306d-bcae-48a3-b5b4-6245fba36c72">PNCAVZZWCJMJ-719779062-26496</_dlc_DocId>
-  </documentManagement>
-</p:properties>
-</file>
-
-<file path=customXml/item2.xml><?xml version="1.0" encoding="utf-8"?>
-<?mso-contentType ?>
-<FormTemplates xmlns="http://schemas.microsoft.com/sharepoint/v3/contenttype/forms">
-  <Display>DocumentLibraryForm</Display>
-  <Edit>DocumentLibraryForm</Edit>
-  <New>DocumentLibraryForm</New>
-</FormTemplates>
-</file>
-
-<file path=customXml/item3.xml><?xml version="1.0" encoding="utf-8"?>
-<?mso-contentType ?>
-<spe:Receivers xmlns:spe="http://schemas.microsoft.com/sharepoint/events">
-  <Receiver>
-    <Name>Document ID Generator</Name>
-    <Synchronization>Synchronous</Synchronization>
-    <Type>10001</Type>
-    <SequenceNumber>1000</SequenceNumber>
-    <Url/>
-    <Assembly>Microsoft.Office.DocumentManagement, Version=16.0.0.0, Culture=neutral, PublicKeyToken=71e9bce111e9429c</Assembly>
-    <Class>Microsoft.Office.DocumentManagement.Internal.DocIdHandler</Class>
-    <Data/>
-    <Filter/>
-  </Receiver>
-  <Receiver>
-    <Name>Document ID Generator</Name>
-    <Synchronization>Synchronous</Synchronization>
-    <Type>10002</Type>
-    <SequenceNumber>1001</SequenceNumber>
-    <Url/>
-    <Assembly>Microsoft.Office.DocumentManagement, Version=16.0.0.0, Culture=neutral, PublicKeyToken=71e9bce111e9429c</Assembly>
-    <Class>Microsoft.Office.DocumentManagement.Internal.DocIdHandler</Class>
-    <Data/>
-    <Filter/>
-  </Receiver>
-  <Receiver>
-    <Name>Document ID Generator</Name>
-    <Synchronization>Synchronous</Synchronization>
-    <Type>10004</Type>
-    <SequenceNumber>1002</SequenceNumber>
-    <Url/>
-    <Assembly>Microsoft.Office.DocumentManagement, Version=16.0.0.0, Culture=neutral, PublicKeyToken=71e9bce111e9429c</Assembly>
-    <Class>Microsoft.Office.DocumentManagement.Internal.DocIdHandler</Class>
-    <Data/>
-    <Filter/>
-  </Receiver>
-  <Receiver>
-    <Name>Document ID Generator</Name>
-    <Synchronization>Synchronous</Synchronization>
-    <Type>10006</Type>
-    <SequenceNumber>1003</SequenceNumber>
-    <Url/>
-    <Assembly>Microsoft.Office.DocumentManagement, Version=16.0.0.0, Culture=neutral, PublicKeyToken=71e9bce111e9429c</Assembly>
-    <Class>Microsoft.Office.DocumentManagement.Internal.DocIdHandler</Class>
-    <Data/>
-    <Filter/>
-  </Receiver>
-</spe:Receivers>
-</file>
-
-<file path=customXml/item4.xml><?xml version="1.0" encoding="utf-8"?>
 <ct:contentTypeSchema xmlns:ct="http://schemas.microsoft.com/office/2006/metadata/contentType" xmlns:ma="http://schemas.microsoft.com/office/2006/metadata/properties/metaAttributes" ct:_="" ma:_="" ma:contentTypeName="Document" ma:contentTypeID="0x010100744FEF590B341F46AAAF568C3B82DA74" ma:contentTypeVersion="126" ma:contentTypeDescription="Create a new document." ma:contentTypeScope="" ma:versionID="da2759216466bc3ec804369b15a902a5">
   <xsd:schema xmlns:xsd="http://www.w3.org/2001/XMLSchema" xmlns:xs="http://www.w3.org/2001/XMLSchema" xmlns:p="http://schemas.microsoft.com/office/2006/metadata/properties" xmlns:ns1="http://schemas.microsoft.com/sharepoint/v3" xmlns:ns2="819a213c-e595-4af7-868c-5311d0f07b09" xmlns:ns3="43c4306d-bcae-48a3-b5b4-6245fba36c72" targetNamespace="http://schemas.microsoft.com/office/2006/metadata/properties" ma:root="true" ma:fieldsID="23a203c7101a14e7e286c2f61aba86b7" ns1:_="" ns2:_="" ns3:_="">
     <xsd:import namespace="http://schemas.microsoft.com/sharepoint/v3"/>
@@ -24364,35 +24278,188 @@
 </ct:contentTypeSchema>
 </file>
 
-<file path=customXml/itemProps1.xml><?xml version="1.0" encoding="utf-8"?>
-<ds:datastoreItem xmlns:ds="http://schemas.openxmlformats.org/officeDocument/2006/customXml" ds:itemID="{C64B5808-DACA-4273-92AE-F78AD06EB5C9}">
-  <ds:schemaRefs>
-    <ds:schemaRef ds:uri="http://schemas.microsoft.com/office/2006/metadata/properties"/>
-    <ds:schemaRef ds:uri="http://schemas.microsoft.com/office/infopath/2007/PartnerControls"/>
-    <ds:schemaRef ds:uri="819a213c-e595-4af7-868c-5311d0f07b09"/>
-    <ds:schemaRef ds:uri="http://schemas.microsoft.com/sharepoint/v3"/>
-    <ds:schemaRef ds:uri="43c4306d-bcae-48a3-b5b4-6245fba36c72"/>
-  </ds:schemaRefs>
-</ds:datastoreItem>
+<file path=customXml/item2.xml><?xml version="1.0" encoding="utf-8"?>
+<?mso-contentType ?>
+<spe:Receivers xmlns:spe="http://schemas.microsoft.com/sharepoint/events">
+  <Receiver>
+    <Name>Document ID Generator</Name>
+    <Synchronization>Synchronous</Synchronization>
+    <Type>10001</Type>
+    <SequenceNumber>1000</SequenceNumber>
+    <Url/>
+    <Assembly>Microsoft.Office.DocumentManagement, Version=16.0.0.0, Culture=neutral, PublicKeyToken=71e9bce111e9429c</Assembly>
+    <Class>Microsoft.Office.DocumentManagement.Internal.DocIdHandler</Class>
+    <Data/>
+    <Filter/>
+  </Receiver>
+  <Receiver>
+    <Name>Document ID Generator</Name>
+    <Synchronization>Synchronous</Synchronization>
+    <Type>10002</Type>
+    <SequenceNumber>1001</SequenceNumber>
+    <Url/>
+    <Assembly>Microsoft.Office.DocumentManagement, Version=16.0.0.0, Culture=neutral, PublicKeyToken=71e9bce111e9429c</Assembly>
+    <Class>Microsoft.Office.DocumentManagement.Internal.DocIdHandler</Class>
+    <Data/>
+    <Filter/>
+  </Receiver>
+  <Receiver>
+    <Name>Document ID Generator</Name>
+    <Synchronization>Synchronous</Synchronization>
+    <Type>10004</Type>
+    <SequenceNumber>1002</SequenceNumber>
+    <Url/>
+    <Assembly>Microsoft.Office.DocumentManagement, Version=16.0.0.0, Culture=neutral, PublicKeyToken=71e9bce111e9429c</Assembly>
+    <Class>Microsoft.Office.DocumentManagement.Internal.DocIdHandler</Class>
+    <Data/>
+    <Filter/>
+  </Receiver>
+  <Receiver>
+    <Name>Document ID Generator</Name>
+    <Synchronization>Synchronous</Synchronization>
+    <Type>10006</Type>
+    <SequenceNumber>1003</SequenceNumber>
+    <Url/>
+    <Assembly>Microsoft.Office.DocumentManagement, Version=16.0.0.0, Culture=neutral, PublicKeyToken=71e9bce111e9429c</Assembly>
+    <Class>Microsoft.Office.DocumentManagement.Internal.DocIdHandler</Class>
+    <Data/>
+    <Filter/>
+  </Receiver>
+</spe:Receivers>
 </file>
 
-<file path=customXml/itemProps2.xml><?xml version="1.0" encoding="utf-8"?>
-<ds:datastoreItem xmlns:ds="http://schemas.openxmlformats.org/officeDocument/2006/customXml" ds:itemID="{D5CBC06A-5433-41AC-89E1-93399C4B6D23}">
-  <ds:schemaRefs>
-    <ds:schemaRef ds:uri="http://schemas.microsoft.com/sharepoint/v3/contenttype/forms"/>
-  </ds:schemaRefs>
-</ds:datastoreItem>
+<file path=customXml/item3.xml><?xml version="1.0" encoding="utf-8"?>
+<?mso-contentType ?>
+<FormTemplates xmlns="http://schemas.microsoft.com/sharepoint/v3/contenttype/forms">
+  <Display>DocumentLibraryForm</Display>
+  <Edit>DocumentLibraryForm</Edit>
+  <New>DocumentLibraryForm</New>
+</FormTemplates>
 </file>
 
-<file path=customXml/itemProps3.xml><?xml version="1.0" encoding="utf-8"?>
-<ds:datastoreItem xmlns:ds="http://schemas.openxmlformats.org/officeDocument/2006/customXml" ds:itemID="{1C5A9CCD-8D95-4E29-9BBC-62ED344D200A}">
-  <ds:schemaRefs>
-    <ds:schemaRef ds:uri="http://schemas.microsoft.com/sharepoint/events"/>
-  </ds:schemaRefs>
-</ds:datastoreItem>
+<file path=customXml/item4.xml><?xml version="1.0" encoding="utf-8"?>
+<p:properties xmlns:p="http://schemas.microsoft.com/office/2006/metadata/properties" xmlns:xsi="http://www.w3.org/2001/XMLSchema-instance" xmlns:pc="http://schemas.microsoft.com/office/infopath/2007/PartnerControls">
+  <documentManagement>
+    <Name_x0028_Outlook_x0029_ xmlns="819a213c-e595-4af7-868c-5311d0f07b09">
+      <UserInfo>
+        <DisplayName/>
+        <AccountId xsi:nil="true"/>
+        <AccountType/>
+      </UserInfo>
+    </Name_x0028_Outlook_x0029_>
+    <_ip_UnifiedCompliancePolicyUIAction xmlns="http://schemas.microsoft.com/sharepoint/v3" xsi:nil="true"/>
+    <TaxCatchAll xmlns="43c4306d-bcae-48a3-b5b4-6245fba36c72">
+      <Value>117</Value>
+      <Value>336</Value>
+      <Value>352</Value>
+      <Value>332</Value>
+      <Value>330</Value>
+      <Value>5</Value>
+      <Value>88</Value>
+      <Value>2</Value>
+      <Value>1</Value>
+    </TaxCatchAll>
+    <Project xmlns="819a213c-e595-4af7-868c-5311d0f07b09">Shrike</Project>
+    <b3e0283348f04d719dc2db6c1ad0eab0 xmlns="819a213c-e595-4af7-868c-5311d0f07b09">
+      <Terms xmlns="http://schemas.microsoft.com/office/infopath/2007/PartnerControls"/>
+    </b3e0283348f04d719dc2db6c1ad0eab0>
+    <kf4578e6b9744d06891b013fb9171991 xmlns="819a213c-e595-4af7-868c-5311d0f07b09">
+      <Terms xmlns="http://schemas.microsoft.com/office/infopath/2007/PartnerControls">
+        <TermInfo xmlns="http://schemas.microsoft.com/office/infopath/2007/PartnerControls">
+          <TermName xmlns="http://schemas.microsoft.com/office/infopath/2007/PartnerControls">FCAI</TermName>
+          <TermId xmlns="http://schemas.microsoft.com/office/infopath/2007/PartnerControls">fd9e9f27-4afa-4bd6-9815-b72522a6dee4</TermId>
+        </TermInfo>
+      </Terms>
+    </kf4578e6b9744d06891b013fb9171991>
+    <e7bf107ab2e246c2ae3b25ccb19c4fe7 xmlns="819a213c-e595-4af7-868c-5311d0f07b09">
+      <Terms xmlns="http://schemas.microsoft.com/office/infopath/2007/PartnerControls"/>
+    </e7bf107ab2e246c2ae3b25ccb19c4fe7>
+    <Status xmlns="819a213c-e595-4af7-868c-5311d0f07b09">NA</Status>
+    <k1cd0d7a50e348e5b2cecacdbb53a3ff xmlns="819a213c-e595-4af7-868c-5311d0f07b09">
+      <Terms xmlns="http://schemas.microsoft.com/office/infopath/2007/PartnerControls">
+        <TermInfo xmlns="http://schemas.microsoft.com/office/infopath/2007/PartnerControls">
+          <TermName xmlns="http://schemas.microsoft.com/office/infopath/2007/PartnerControls">NA</TermName>
+          <TermId xmlns="http://schemas.microsoft.com/office/infopath/2007/PartnerControls">6c779868-fdfe-4433-a583-74f72965e832</TermId>
+        </TermInfo>
+      </Terms>
+    </k1cd0d7a50e348e5b2cecacdbb53a3ff>
+    <k4bd3d618c344bb496a0035fa1bfa95e xmlns="819a213c-e595-4af7-868c-5311d0f07b09">
+      <Terms xmlns="http://schemas.microsoft.com/office/infopath/2007/PartnerControls">
+        <TermInfo xmlns="http://schemas.microsoft.com/office/infopath/2007/PartnerControls">
+          <TermName xmlns="http://schemas.microsoft.com/office/infopath/2007/PartnerControls">NA</TermName>
+          <TermId xmlns="http://schemas.microsoft.com/office/infopath/2007/PartnerControls">14e9068e-14f9-49cc-a753-38a742264b27</TermId>
+        </TermInfo>
+      </Terms>
+    </k4bd3d618c344bb496a0035fa1bfa95e>
+    <m3911d227d12438196938f21bccbb829 xmlns="819a213c-e595-4af7-868c-5311d0f07b09">
+      <Terms xmlns="http://schemas.microsoft.com/office/infopath/2007/PartnerControls">
+        <TermInfo xmlns="http://schemas.microsoft.com/office/infopath/2007/PartnerControls">
+          <TermName xmlns="http://schemas.microsoft.com/office/infopath/2007/PartnerControls">Unclassified</TermName>
+          <TermId xmlns="http://schemas.microsoft.com/office/infopath/2007/PartnerControls">0e44ab2e-9e75-4d69-bacf-b9adbba64961</TermId>
+        </TermInfo>
+      </Terms>
+    </m3911d227d12438196938f21bccbb829>
+    <j85403ed819e4ad59bb8aa44734c7278 xmlns="819a213c-e595-4af7-868c-5311d0f07b09">
+      <Terms xmlns="http://schemas.microsoft.com/office/infopath/2007/PartnerControls">
+        <TermInfo xmlns="http://schemas.microsoft.com/office/infopath/2007/PartnerControls">
+          <TermName xmlns="http://schemas.microsoft.com/office/infopath/2007/PartnerControls">NA</TermName>
+          <TermId xmlns="http://schemas.microsoft.com/office/infopath/2007/PartnerControls">c413e2e5-7da6-4fb4-9318-c07a4c95104c</TermId>
+        </TermInfo>
+      </Terms>
+    </j85403ed819e4ad59bb8aa44734c7278>
+    <e41571422c3345b4bda9d3ac979b0442 xmlns="819a213c-e595-4af7-868c-5311d0f07b09">
+      <Terms xmlns="http://schemas.microsoft.com/office/infopath/2007/PartnerControls">
+        <TermInfo xmlns="http://schemas.microsoft.com/office/infopath/2007/PartnerControls">
+          <TermName xmlns="http://schemas.microsoft.com/office/infopath/2007/PartnerControls">Destroy</TermName>
+          <TermId xmlns="http://schemas.microsoft.com/office/infopath/2007/PartnerControls">81460359-14dd-47b4-9102-5fada66d1614</TermId>
+        </TermInfo>
+      </Terms>
+    </e41571422c3345b4bda9d3ac979b0442>
+    <b2c7cbb6fa064dd095a8ebf73878e15c xmlns="819a213c-e595-4af7-868c-5311d0f07b09">
+      <Terms xmlns="http://schemas.microsoft.com/office/infopath/2007/PartnerControls">
+        <TermInfo xmlns="http://schemas.microsoft.com/office/infopath/2007/PartnerControls">
+          <TermName xmlns="http://schemas.microsoft.com/office/infopath/2007/PartnerControls">D</TermName>
+          <TermId xmlns="http://schemas.microsoft.com/office/infopath/2007/PartnerControls">e66b2925-d207-445d-a7ac-7bf5587a61c3</TermId>
+        </TermInfo>
+      </Terms>
+    </b2c7cbb6fa064dd095a8ebf73878e15c>
+    <n050dff107b041e7a8136cabb03c9f16 xmlns="819a213c-e595-4af7-868c-5311d0f07b09">
+      <Terms xmlns="http://schemas.microsoft.com/office/infopath/2007/PartnerControls"/>
+    </n050dff107b041e7a8136cabb03c9f16>
+    <dbcc5996da9743a2aff52ccb96daf316 xmlns="819a213c-e595-4af7-868c-5311d0f07b09">
+      <Terms xmlns="http://schemas.microsoft.com/office/infopath/2007/PartnerControls"/>
+    </dbcc5996da9743a2aff52ccb96daf316>
+    <_ip_UnifiedCompliancePolicyProperties xmlns="http://schemas.microsoft.com/sharepoint/v3" xsi:nil="true"/>
+    <Comments xmlns="819a213c-e595-4af7-868c-5311d0f07b09" xsi:nil="true"/>
+    <_dlc_DocIdPersistId xmlns="43c4306d-bcae-48a3-b5b4-6245fba36c72" xsi:nil="true"/>
+    <_dlc_DocIdUrl xmlns="43c4306d-bcae-48a3-b5b4-6245fba36c72">
+      <Url>https://armyeitaas.sharepoint-mil.us/teams/AI2CKMDevelopmentTeam/_layouts/15/DocIdRedir.aspx?ID=PNCAVZZWCJMJ-719779062-26496</Url>
+      <Description>PNCAVZZWCJMJ-719779062-26496</Description>
+    </_dlc_DocIdUrl>
+    <Teams xmlns="819a213c-e595-4af7-868c-5311d0f07b09">NA</Teams>
+    <lcf76f155ced4ddcb4097134ff3c332f xmlns="819a213c-e595-4af7-868c-5311d0f07b09">
+      <Terms xmlns="http://schemas.microsoft.com/office/infopath/2007/PartnerControls"/>
+    </lcf76f155ced4ddcb4097134ff3c332f>
+    <kf187aa08ef840c0be306c2b7cf181cc xmlns="819a213c-e595-4af7-868c-5311d0f07b09">
+      <Terms xmlns="http://schemas.microsoft.com/office/infopath/2007/PartnerControls"/>
+    </kf187aa08ef840c0be306c2b7cf181cc>
+    <k8ed72fc0ac74230bc2bce9a30aa3ff1 xmlns="819a213c-e595-4af7-868c-5311d0f07b09">
+      <Terms xmlns="http://schemas.microsoft.com/office/infopath/2007/PartnerControls"/>
+    </k8ed72fc0ac74230bc2bce9a30aa3ff1>
+    <j3cec2dc15da4ea9ae4c2914aab734b8 xmlns="819a213c-e595-4af7-868c-5311d0f07b09">
+      <Terms xmlns="http://schemas.microsoft.com/office/infopath/2007/PartnerControls">
+        <TermInfo xmlns="http://schemas.microsoft.com/office/infopath/2007/PartnerControls">
+          <TermName xmlns="http://schemas.microsoft.com/office/infopath/2007/PartnerControls">Unofficial</TermName>
+          <TermId xmlns="http://schemas.microsoft.com/office/infopath/2007/PartnerControls">fb72a3e1-cd07-4e90-8aa1-1e35bcf7448f</TermId>
+        </TermInfo>
+      </Terms>
+    </j3cec2dc15da4ea9ae4c2914aab734b8>
+    <_dlc_DocId xmlns="43c4306d-bcae-48a3-b5b4-6245fba36c72">PNCAVZZWCJMJ-719779062-26496</_dlc_DocId>
+  </documentManagement>
+</p:properties>
 </file>
 
-<file path=customXml/itemProps4.xml><?xml version="1.0" encoding="utf-8"?>
+<file path=customXml/itemProps1.xml><?xml version="1.0" encoding="utf-8"?>
 <ds:datastoreItem xmlns:ds="http://schemas.openxmlformats.org/officeDocument/2006/customXml" ds:itemID="{8F325A96-F9CD-4C1F-BC68-5ED8156DC1C7}">
   <ds:schemaRefs>
     <ds:schemaRef ds:uri="http://schemas.microsoft.com/office/2006/metadata/contentType"/>
@@ -24412,6 +24479,34 @@
 </ds:datastoreItem>
 </file>
 
+<file path=customXml/itemProps2.xml><?xml version="1.0" encoding="utf-8"?>
+<ds:datastoreItem xmlns:ds="http://schemas.openxmlformats.org/officeDocument/2006/customXml" ds:itemID="{1C5A9CCD-8D95-4E29-9BBC-62ED344D200A}">
+  <ds:schemaRefs>
+    <ds:schemaRef ds:uri="http://schemas.microsoft.com/sharepoint/events"/>
+  </ds:schemaRefs>
+</ds:datastoreItem>
+</file>
+
+<file path=customXml/itemProps3.xml><?xml version="1.0" encoding="utf-8"?>
+<ds:datastoreItem xmlns:ds="http://schemas.openxmlformats.org/officeDocument/2006/customXml" ds:itemID="{D5CBC06A-5433-41AC-89E1-93399C4B6D23}">
+  <ds:schemaRefs>
+    <ds:schemaRef ds:uri="http://schemas.microsoft.com/sharepoint/v3/contenttype/forms"/>
+  </ds:schemaRefs>
+</ds:datastoreItem>
+</file>
+
+<file path=customXml/itemProps4.xml><?xml version="1.0" encoding="utf-8"?>
+<ds:datastoreItem xmlns:ds="http://schemas.openxmlformats.org/officeDocument/2006/customXml" ds:itemID="{C64B5808-DACA-4273-92AE-F78AD06EB5C9}">
+  <ds:schemaRefs>
+    <ds:schemaRef ds:uri="http://schemas.microsoft.com/office/2006/metadata/properties"/>
+    <ds:schemaRef ds:uri="http://schemas.microsoft.com/office/infopath/2007/PartnerControls"/>
+    <ds:schemaRef ds:uri="819a213c-e595-4af7-868c-5311d0f07b09"/>
+    <ds:schemaRef ds:uri="http://schemas.microsoft.com/sharepoint/v3"/>
+    <ds:schemaRef ds:uri="43c4306d-bcae-48a3-b5b4-6245fba36c72"/>
+  </ds:schemaRefs>
+</ds:datastoreItem>
+</file>
+
 <file path=docMetadata/LabelInfo.xml><?xml version="1.0" encoding="utf-8"?>
 <clbl:labelList xmlns:clbl="http://schemas.microsoft.com/office/2020/mipLabelMetadata">
   <clbl:label id="{554eecc5-e26c-4620-b240-5a8bb326c33d}" enabled="1" method="Privileged" siteId="{fae6d70f-954b-4811-92b6-0530d6f84c43}" contentBits="0" removed="0"/>

</xml_diff>